<commit_message>
fix(ppt): set explicit 16:9 widescreen layout and constrain card bounds so elements stay within slide borders
</commit_message>
<xml_diff>
--- a/VoiceChessmate_HACKDAY_1.0.pptx
+++ b/VoiceChessmate_HACKDAY_1.0.pptx
@@ -16,8 +16,8 @@
   <p:notesMasterIdLst>
     <p:notesMasterId r:id="rId9"/>
   </p:notesMasterIdLst>
-  <p:sldSz cx="9144000" cy="5143500"/>
-  <p:notesSz cx="5143500" cy="9144000"/>
+  <p:sldSz cx="12191695" cy="6858000"/>
+  <p:notesSz cx="6858000" cy="12191695"/>
   <p:defaultTextStyle>
     <a:lvl1pPr marL="0" algn="l" defTabSz="914400" rtl="0" eaLnBrk="1" latinLnBrk="0" hangingPunct="1">
       <a:defRPr sz="1800" kern="1200">
@@ -1417,7 +1417,7 @@
         </p:nvSpPr>
         <p:spPr>
           <a:xfrm>
-            <a:off x="731520" y="457200"/>
+            <a:off x="731520" y="411480"/>
             <a:ext cx="2011680" cy="292608"/>
           </a:xfrm>
           <a:prstGeom prst="roundRect">
@@ -1444,7 +1444,7 @@
         </p:nvSpPr>
         <p:spPr>
           <a:xfrm>
-            <a:off x="731520" y="457200"/>
+            <a:off x="731520" y="411480"/>
             <a:ext cx="2011680" cy="292608"/>
           </a:xfrm>
           <a:prstGeom prst="rect">
@@ -1483,24 +1483,24 @@
         </p:nvSpPr>
         <p:spPr>
           <a:xfrm>
-            <a:off x="731520" y="822960"/>
-            <a:ext cx="10515600" cy="640080"/>
-          </a:xfrm>
-          <a:prstGeom prst="rect">
-            <a:avLst/>
-          </a:prstGeom>
-          <a:noFill/>
-          <a:ln/>
-        </p:spPr>
-        <p:txBody>
-          <a:bodyPr wrap="square" rtlCol="0" anchor="ctr"/>
-          <a:lstStyle/>
-          <a:p>
-            <a:pPr indent="0" marL="0">
-              <a:buNone/>
-            </a:pPr>
-            <a:r>
-              <a:rPr lang="en-US" sz="2400" b="1" dirty="0">
+            <a:off x="731520" y="777240"/>
+            <a:ext cx="10698480" cy="594360"/>
+          </a:xfrm>
+          <a:prstGeom prst="rect">
+            <a:avLst/>
+          </a:prstGeom>
+          <a:noFill/>
+          <a:ln/>
+        </p:spPr>
+        <p:txBody>
+          <a:bodyPr wrap="square" rtlCol="0" anchor="ctr"/>
+          <a:lstStyle/>
+          <a:p>
+            <a:pPr indent="0" marL="0">
+              <a:buNone/>
+            </a:pPr>
+            <a:r>
+              <a:rPr lang="en-US" sz="2200" b="1" dirty="0">
                 <a:solidFill>
                   <a:srgbClr val="E8F4EE"/>
                 </a:solidFill>
@@ -1510,7 +1510,7 @@
               </a:rPr>
               <a:t>Chess is Global. Digital Chess Locks Out 285M Blind Players.</a:t>
             </a:r>
-            <a:endParaRPr lang="en-US" sz="2400" dirty="0"/>
+            <a:endParaRPr lang="en-US" sz="2200" dirty="0"/>
           </a:p>
         </p:txBody>
       </p:sp>
@@ -1522,12 +1522,12 @@
         </p:nvSpPr>
         <p:spPr>
           <a:xfrm>
-            <a:off x="731520" y="1737360"/>
-            <a:ext cx="3429000" cy="4389120"/>
+            <a:off x="731520" y="1600200"/>
+            <a:ext cx="3337560" cy="4389120"/>
           </a:xfrm>
           <a:prstGeom prst="roundRect">
             <a:avLst>
-              <a:gd name="adj" fmla="val 4000"/>
+              <a:gd name="adj" fmla="val 4110"/>
             </a:avLst>
           </a:prstGeom>
           <a:solidFill>
@@ -1563,8 +1563,8 @@
         </p:blipFill>
         <p:spPr>
           <a:xfrm>
-            <a:off x="1097280" y="2103120"/>
-            <a:ext cx="502920" cy="502920"/>
+            <a:off x="1051560" y="1920240"/>
+            <a:ext cx="457200" cy="457200"/>
           </a:xfrm>
           <a:prstGeom prst="rect">
             <a:avLst/>
@@ -1579,8 +1579,8 @@
         </p:nvSpPr>
         <p:spPr>
           <a:xfrm>
-            <a:off x="1097280" y="2834640"/>
-            <a:ext cx="2697480" cy="731520"/>
+            <a:off x="1051560" y="2560320"/>
+            <a:ext cx="2697480" cy="548640"/>
           </a:xfrm>
           <a:prstGeom prst="rect">
             <a:avLst/>
@@ -1618,8 +1618,8 @@
         </p:nvSpPr>
         <p:spPr>
           <a:xfrm>
-            <a:off x="1097280" y="3657600"/>
-            <a:ext cx="2697480" cy="2103120"/>
+            <a:off x="1051560" y="3291840"/>
+            <a:ext cx="2697480" cy="2377440"/>
           </a:xfrm>
           <a:prstGeom prst="rect">
             <a:avLst/>
@@ -1638,7 +1638,7 @@
               <a:buNone/>
             </a:pPr>
             <a:r>
-              <a:rPr lang="en-US" sz="1300" dirty="0">
+              <a:rPr lang="en-US" sz="1250" dirty="0">
                 <a:solidFill>
                   <a:srgbClr val="9AB4A5"/>
                 </a:solidFill>
@@ -1648,7 +1648,7 @@
               </a:rPr>
               <a:t>Mainstream platforms (Chess.com, Lichess) demand constant 2D eye tracking across 64 squares. Fast-paced Blitz &amp; Bullet games are physically impossible for blind players.</a:t>
             </a:r>
-            <a:endParaRPr lang="en-US" sz="1300" dirty="0"/>
+            <a:endParaRPr lang="en-US" sz="1250" dirty="0"/>
           </a:p>
         </p:txBody>
       </p:sp>
@@ -1660,12 +1660,12 @@
         </p:nvSpPr>
         <p:spPr>
           <a:xfrm>
-            <a:off x="4343400" y="1737360"/>
-            <a:ext cx="3429000" cy="4389120"/>
+            <a:off x="4416552" y="1600200"/>
+            <a:ext cx="3337560" cy="4389120"/>
           </a:xfrm>
           <a:prstGeom prst="roundRect">
             <a:avLst>
-              <a:gd name="adj" fmla="val 4000"/>
+              <a:gd name="adj" fmla="val 4110"/>
             </a:avLst>
           </a:prstGeom>
           <a:solidFill>
@@ -1701,8 +1701,8 @@
         </p:blipFill>
         <p:spPr>
           <a:xfrm>
-            <a:off x="4709160" y="2103120"/>
-            <a:ext cx="502920" cy="502920"/>
+            <a:off x="4736592" y="1920240"/>
+            <a:ext cx="457200" cy="457200"/>
           </a:xfrm>
           <a:prstGeom prst="rect">
             <a:avLst/>
@@ -1717,8 +1717,8 @@
         </p:nvSpPr>
         <p:spPr>
           <a:xfrm>
-            <a:off x="4709160" y="2834640"/>
-            <a:ext cx="2697480" cy="731520"/>
+            <a:off x="4736592" y="2560320"/>
+            <a:ext cx="2697480" cy="548640"/>
           </a:xfrm>
           <a:prstGeom prst="rect">
             <a:avLst/>
@@ -1742,7 +1742,7 @@
                 <a:ea typeface="Arial" pitchFamily="34" charset="-122"/>
                 <a:cs typeface="Arial" pitchFamily="34" charset="-120"/>
               </a:rPr>
-              <a:t>Screen Reader Friction &amp; Latency</a:t>
+              <a:t>Screen Reader Friction</a:t>
             </a:r>
             <a:endParaRPr lang="en-US" sz="1600" dirty="0"/>
           </a:p>
@@ -1756,8 +1756,8 @@
         </p:nvSpPr>
         <p:spPr>
           <a:xfrm>
-            <a:off x="4709160" y="3657600"/>
-            <a:ext cx="2697480" cy="2103120"/>
+            <a:off x="4736592" y="3291840"/>
+            <a:ext cx="2697480" cy="2377440"/>
           </a:xfrm>
           <a:prstGeom prst="rect">
             <a:avLst/>
@@ -1776,7 +1776,7 @@
               <a:buNone/>
             </a:pPr>
             <a:r>
-              <a:rPr lang="en-US" sz="1300" dirty="0">
+              <a:rPr lang="en-US" sz="1250" dirty="0">
                 <a:solidFill>
                   <a:srgbClr val="9AB4A5"/>
                 </a:solidFill>
@@ -1786,7 +1786,7 @@
               </a:rPr>
               <a:t>Screen readers read raw DOM tables cell by cell. This adds 6-10 seconds of cognitive and mechanical delay per move, making clock flag-falls inevitable.</a:t>
             </a:r>
-            <a:endParaRPr lang="en-US" sz="1300" dirty="0"/>
+            <a:endParaRPr lang="en-US" sz="1250" dirty="0"/>
           </a:p>
         </p:txBody>
       </p:sp>
@@ -1798,12 +1798,12 @@
         </p:nvSpPr>
         <p:spPr>
           <a:xfrm>
-            <a:off x="7955280" y="1737360"/>
-            <a:ext cx="3429000" cy="4389120"/>
+            <a:off x="8101584" y="1600200"/>
+            <a:ext cx="3337560" cy="4389120"/>
           </a:xfrm>
           <a:prstGeom prst="roundRect">
             <a:avLst>
-              <a:gd name="adj" fmla="val 4000"/>
+              <a:gd name="adj" fmla="val 4110"/>
             </a:avLst>
           </a:prstGeom>
           <a:solidFill>
@@ -1839,8 +1839,8 @@
         </p:blipFill>
         <p:spPr>
           <a:xfrm>
-            <a:off x="8321040" y="2103120"/>
-            <a:ext cx="502920" cy="502920"/>
+            <a:off x="8421624" y="1920240"/>
+            <a:ext cx="457200" cy="457200"/>
           </a:xfrm>
           <a:prstGeom prst="rect">
             <a:avLst/>
@@ -1855,8 +1855,8 @@
         </p:nvSpPr>
         <p:spPr>
           <a:xfrm>
-            <a:off x="8321040" y="2834640"/>
-            <a:ext cx="2697480" cy="731520"/>
+            <a:off x="8421624" y="2560320"/>
+            <a:ext cx="2697480" cy="548640"/>
           </a:xfrm>
           <a:prstGeom prst="rect">
             <a:avLst/>
@@ -1894,8 +1894,8 @@
         </p:nvSpPr>
         <p:spPr>
           <a:xfrm>
-            <a:off x="8321040" y="3657600"/>
-            <a:ext cx="2697480" cy="2103120"/>
+            <a:off x="8421624" y="3291840"/>
+            <a:ext cx="2697480" cy="2377440"/>
           </a:xfrm>
           <a:prstGeom prst="rect">
             <a:avLst/>
@@ -1914,7 +1914,7 @@
               <a:buNone/>
             </a:pPr>
             <a:r>
-              <a:rPr lang="en-US" sz="1300" dirty="0">
+              <a:rPr lang="en-US" sz="1250" dirty="0">
                 <a:solidFill>
                   <a:srgbClr val="9AB4A5"/>
                 </a:solidFill>
@@ -1924,7 +1924,7 @@
               </a:rPr>
               <a:t>Coordinate readouts lack domain insight. Players have no instantaneous awareness of hanging pieces, pins, discovered attacks, or checkmate patterns.</a:t>
             </a:r>
-            <a:endParaRPr lang="en-US" sz="1300" dirty="0"/>
+            <a:endParaRPr lang="en-US" sz="1250" dirty="0"/>
           </a:p>
         </p:txBody>
       </p:sp>
@@ -1968,7 +1968,7 @@
         </p:nvSpPr>
         <p:spPr>
           <a:xfrm>
-            <a:off x="731520" y="457200"/>
+            <a:off x="731520" y="411480"/>
             <a:ext cx="2011680" cy="292608"/>
           </a:xfrm>
           <a:prstGeom prst="roundRect">
@@ -1995,7 +1995,7 @@
         </p:nvSpPr>
         <p:spPr>
           <a:xfrm>
-            <a:off x="731520" y="457200"/>
+            <a:off x="731520" y="411480"/>
             <a:ext cx="2011680" cy="292608"/>
           </a:xfrm>
           <a:prstGeom prst="rect">
@@ -2034,24 +2034,24 @@
         </p:nvSpPr>
         <p:spPr>
           <a:xfrm>
-            <a:off x="731520" y="822960"/>
-            <a:ext cx="10515600" cy="640080"/>
-          </a:xfrm>
-          <a:prstGeom prst="rect">
-            <a:avLst/>
-          </a:prstGeom>
-          <a:noFill/>
-          <a:ln/>
-        </p:spPr>
-        <p:txBody>
-          <a:bodyPr wrap="square" rtlCol="0" anchor="ctr"/>
-          <a:lstStyle/>
-          <a:p>
-            <a:pPr indent="0" marL="0">
-              <a:buNone/>
-            </a:pPr>
-            <a:r>
-              <a:rPr lang="en-US" sz="2400" b="1" dirty="0">
+            <a:off x="731520" y="777240"/>
+            <a:ext cx="10698480" cy="594360"/>
+          </a:xfrm>
+          <a:prstGeom prst="rect">
+            <a:avLst/>
+          </a:prstGeom>
+          <a:noFill/>
+          <a:ln/>
+        </p:spPr>
+        <p:txBody>
+          <a:bodyPr wrap="square" rtlCol="0" anchor="ctr"/>
+          <a:lstStyle/>
+          <a:p>
+            <a:pPr indent="0" marL="0">
+              <a:buNone/>
+            </a:pPr>
+            <a:r>
+              <a:rPr lang="en-US" sz="2200" b="1" dirty="0">
                 <a:solidFill>
                   <a:srgbClr val="E8F4EE"/>
                 </a:solidFill>
@@ -2061,7 +2061,7 @@
               </a:rPr>
               <a:t>VoiceChessmate: The Eyes-Free, Voice-First Chess Companion</a:t>
             </a:r>
-            <a:endParaRPr lang="en-US" sz="2400" dirty="0"/>
+            <a:endParaRPr lang="en-US" sz="2200" dirty="0"/>
           </a:p>
         </p:txBody>
       </p:sp>
@@ -2073,8 +2073,8 @@
         </p:nvSpPr>
         <p:spPr>
           <a:xfrm>
-            <a:off x="731520" y="1737360"/>
-            <a:ext cx="5303520" cy="4389120"/>
+            <a:off x="731520" y="1600200"/>
+            <a:ext cx="5166360" cy="4389120"/>
           </a:xfrm>
           <a:prstGeom prst="roundRect">
             <a:avLst>
@@ -2114,8 +2114,8 @@
         </p:blipFill>
         <p:spPr>
           <a:xfrm>
-            <a:off x="1097280" y="2103120"/>
-            <a:ext cx="502920" cy="502920"/>
+            <a:off x="1051560" y="1920240"/>
+            <a:ext cx="457200" cy="457200"/>
           </a:xfrm>
           <a:prstGeom prst="rect">
             <a:avLst/>
@@ -2130,24 +2130,24 @@
         </p:nvSpPr>
         <p:spPr>
           <a:xfrm>
-            <a:off x="1737360" y="2148840"/>
-            <a:ext cx="4023360" cy="365760"/>
-          </a:xfrm>
-          <a:prstGeom prst="rect">
-            <a:avLst/>
-          </a:prstGeom>
-          <a:noFill/>
-          <a:ln/>
-        </p:spPr>
-        <p:txBody>
-          <a:bodyPr wrap="square" rtlCol="0" anchor="ctr"/>
-          <a:lstStyle/>
-          <a:p>
-            <a:pPr indent="0" marL="0">
-              <a:buNone/>
-            </a:pPr>
-            <a:r>
-              <a:rPr lang="en-US" sz="1800" b="1" dirty="0">
+            <a:off x="1645920" y="1965960"/>
+            <a:ext cx="4069080" cy="365760"/>
+          </a:xfrm>
+          <a:prstGeom prst="rect">
+            <a:avLst/>
+          </a:prstGeom>
+          <a:noFill/>
+          <a:ln/>
+        </p:spPr>
+        <p:txBody>
+          <a:bodyPr wrap="square" rtlCol="0" anchor="ctr"/>
+          <a:lstStyle/>
+          <a:p>
+            <a:pPr indent="0" marL="0">
+              <a:buNone/>
+            </a:pPr>
+            <a:r>
+              <a:rPr lang="en-US" sz="1700" b="1" dirty="0">
                 <a:solidFill>
                   <a:srgbClr val="FFFFFF"/>
                 </a:solidFill>
@@ -2157,7 +2157,7 @@
               </a:rPr>
               <a:t>Natural Conversational Chess</a:t>
             </a:r>
-            <a:endParaRPr lang="en-US" sz="1800" dirty="0"/>
+            <a:endParaRPr lang="en-US" sz="1700" dirty="0"/>
           </a:p>
         </p:txBody>
       </p:sp>
@@ -2169,8 +2169,8 @@
         </p:nvSpPr>
         <p:spPr>
           <a:xfrm>
-            <a:off x="1097280" y="2834640"/>
-            <a:ext cx="4572000" cy="2926080"/>
+            <a:off x="1051560" y="2606040"/>
+            <a:ext cx="4526280" cy="3017520"/>
           </a:xfrm>
           <a:prstGeom prst="rect">
             <a:avLst/>
@@ -2184,12 +2184,12 @@
           <a:p>
             <a:pPr indent="0" marL="0">
               <a:lnSpc>
-                <a:spcPts val="2000"/>
+                <a:spcPts val="1900"/>
               </a:lnSpc>
               <a:buNone/>
             </a:pPr>
             <a:r>
-              <a:rPr lang="en-US" sz="1400" dirty="0">
+              <a:rPr lang="en-US" sz="1300" dirty="0">
                 <a:solidFill>
                   <a:srgbClr val="9AB4A5"/>
                 </a:solidFill>
@@ -2199,17 +2199,17 @@
               </a:rPr>
               <a:t>Players simply hold 'J' (push-to-talk) and speak naturally:</a:t>
             </a:r>
-            <a:endParaRPr lang="en-US" sz="1400" dirty="0"/>
+            <a:endParaRPr lang="en-US" sz="1300" dirty="0"/>
           </a:p>
           <a:p>
             <a:pPr indent="0" marL="0">
               <a:lnSpc>
-                <a:spcPts val="2000"/>
+                <a:spcPts val="1900"/>
               </a:lnSpc>
               <a:buNone/>
             </a:pPr>
             <a:r>
-              <a:rPr lang="en-US" sz="1400" dirty="0">
+              <a:rPr lang="en-US" sz="1300" dirty="0">
                 <a:solidFill>
                   <a:srgbClr val="9AB4A5"/>
                 </a:solidFill>
@@ -2219,17 +2219,17 @@
               </a:rPr>
               <a:t>  • 'Knight to f3' or 'Pawn to Eva 4'</a:t>
             </a:r>
-            <a:endParaRPr lang="en-US" sz="1400" dirty="0"/>
+            <a:endParaRPr lang="en-US" sz="1300" dirty="0"/>
           </a:p>
           <a:p>
             <a:pPr indent="0" marL="0">
               <a:lnSpc>
-                <a:spcPts val="2000"/>
+                <a:spcPts val="1900"/>
               </a:lnSpc>
               <a:buNone/>
             </a:pPr>
             <a:r>
-              <a:rPr lang="en-US" sz="1400" dirty="0">
+              <a:rPr lang="en-US" sz="1300" dirty="0">
                 <a:solidFill>
                   <a:srgbClr val="9AB4A5"/>
                 </a:solidFill>
@@ -2239,26 +2239,26 @@
               </a:rPr>
               <a:t>  • 'Describe my threats' or 'What is my best development?'</a:t>
             </a:r>
-            <a:endParaRPr lang="en-US" sz="1400" dirty="0"/>
+            <a:endParaRPr lang="en-US" sz="1300" dirty="0"/>
           </a:p>
           <a:p>
             <a:pPr indent="0" marL="0">
               <a:lnSpc>
-                <a:spcPts val="2000"/>
+                <a:spcPts val="1900"/>
               </a:lnSpc>
               <a:buNone/>
             </a:pPr>
-            <a:endParaRPr lang="en-US" sz="1400" dirty="0"/>
+            <a:endParaRPr lang="en-US" sz="1300" dirty="0"/>
           </a:p>
           <a:p>
             <a:pPr indent="0" marL="0">
               <a:lnSpc>
-                <a:spcPts val="2000"/>
+                <a:spcPts val="1900"/>
               </a:lnSpc>
               <a:buNone/>
             </a:pPr>
             <a:r>
-              <a:rPr lang="en-US" sz="1400" dirty="0">
+              <a:rPr lang="en-US" sz="1300" dirty="0">
                 <a:solidFill>
                   <a:srgbClr val="9AB4A5"/>
                 </a:solidFill>
@@ -2268,7 +2268,7 @@
               </a:rPr>
               <a:t>The Voice Agent immediately confirms moves, executes the AI reply, and speaks tactical coaching guidance back with zero screen dependency.</a:t>
             </a:r>
-            <a:endParaRPr lang="en-US" sz="1400" dirty="0"/>
+            <a:endParaRPr lang="en-US" sz="1300" dirty="0"/>
           </a:p>
         </p:txBody>
       </p:sp>
@@ -2280,12 +2280,12 @@
         </p:nvSpPr>
         <p:spPr>
           <a:xfrm>
-            <a:off x="6309360" y="1737360"/>
-            <a:ext cx="5120640" cy="1325880"/>
+            <a:off x="6263640" y="1600200"/>
+            <a:ext cx="5166360" cy="1371600"/>
           </a:xfrm>
           <a:prstGeom prst="roundRect">
             <a:avLst>
-              <a:gd name="adj" fmla="val 10345"/>
+              <a:gd name="adj" fmla="val 10000"/>
             </a:avLst>
           </a:prstGeom>
           <a:solidFill>
@@ -2321,7 +2321,7 @@
         </p:blipFill>
         <p:spPr>
           <a:xfrm>
-            <a:off x="6583680" y="2057400"/>
+            <a:off x="6537960" y="1920240"/>
             <a:ext cx="411480" cy="411480"/>
           </a:xfrm>
           <a:prstGeom prst="rect">
@@ -2337,8 +2337,8 @@
         </p:nvSpPr>
         <p:spPr>
           <a:xfrm>
-            <a:off x="7132320" y="1965960"/>
-            <a:ext cx="4023360" cy="320040"/>
+            <a:off x="7086600" y="1828800"/>
+            <a:ext cx="4160520" cy="320040"/>
           </a:xfrm>
           <a:prstGeom prst="rect">
             <a:avLst/>
@@ -2376,24 +2376,27 @@
         </p:nvSpPr>
         <p:spPr>
           <a:xfrm>
-            <a:off x="7132320" y="2331720"/>
-            <a:ext cx="4023360" cy="594360"/>
-          </a:xfrm>
-          <a:prstGeom prst="rect">
-            <a:avLst/>
-          </a:prstGeom>
-          <a:noFill/>
-          <a:ln/>
-        </p:spPr>
-        <p:txBody>
-          <a:bodyPr wrap="square" rtlCol="0" anchor="ctr"/>
-          <a:lstStyle/>
-          <a:p>
-            <a:pPr indent="0" marL="0">
-              <a:buNone/>
-            </a:pPr>
-            <a:r>
-              <a:rPr lang="en-US" sz="1200" dirty="0">
+            <a:off x="7086600" y="2194560"/>
+            <a:ext cx="4160520" cy="640080"/>
+          </a:xfrm>
+          <a:prstGeom prst="rect">
+            <a:avLst/>
+          </a:prstGeom>
+          <a:noFill/>
+          <a:ln/>
+        </p:spPr>
+        <p:txBody>
+          <a:bodyPr wrap="square" rtlCol="0" anchor="ctr"/>
+          <a:lstStyle/>
+          <a:p>
+            <a:pPr indent="0" marL="0">
+              <a:lnSpc>
+                <a:spcPts val="1500"/>
+              </a:lnSpc>
+              <a:buNone/>
+            </a:pPr>
+            <a:r>
+              <a:rPr lang="en-US" sz="1150" dirty="0">
                 <a:solidFill>
                   <a:srgbClr val="9AB4A5"/>
                 </a:solidFill>
@@ -2403,7 +2406,7 @@
               </a:rPr>
               <a:t>Dual AudioContext: 48kHz native playback + 24kHz capture with realistic wooden piece acoustics.</a:t>
             </a:r>
-            <a:endParaRPr lang="en-US" sz="1200" dirty="0"/>
+            <a:endParaRPr lang="en-US" sz="1150" dirty="0"/>
           </a:p>
         </p:txBody>
       </p:sp>
@@ -2415,12 +2418,12 @@
         </p:nvSpPr>
         <p:spPr>
           <a:xfrm>
-            <a:off x="6309360" y="3246120"/>
-            <a:ext cx="5120640" cy="1325880"/>
+            <a:off x="6263640" y="3108960"/>
+            <a:ext cx="5166360" cy="1371600"/>
           </a:xfrm>
           <a:prstGeom prst="roundRect">
             <a:avLst>
-              <a:gd name="adj" fmla="val 10345"/>
+              <a:gd name="adj" fmla="val 10000"/>
             </a:avLst>
           </a:prstGeom>
           <a:solidFill>
@@ -2456,7 +2459,7 @@
         </p:blipFill>
         <p:spPr>
           <a:xfrm>
-            <a:off x="6583680" y="3566160"/>
+            <a:off x="6537960" y="3429000"/>
             <a:ext cx="411480" cy="411480"/>
           </a:xfrm>
           <a:prstGeom prst="rect">
@@ -2472,8 +2475,8 @@
         </p:nvSpPr>
         <p:spPr>
           <a:xfrm>
-            <a:off x="7132320" y="3474720"/>
-            <a:ext cx="4023360" cy="320040"/>
+            <a:off x="7086600" y="3337560"/>
+            <a:ext cx="4160520" cy="320040"/>
           </a:xfrm>
           <a:prstGeom prst="rect">
             <a:avLst/>
@@ -2511,24 +2514,27 @@
         </p:nvSpPr>
         <p:spPr>
           <a:xfrm>
-            <a:off x="7132320" y="3840480"/>
-            <a:ext cx="4023360" cy="594360"/>
-          </a:xfrm>
-          <a:prstGeom prst="rect">
-            <a:avLst/>
-          </a:prstGeom>
-          <a:noFill/>
-          <a:ln/>
-        </p:spPr>
-        <p:txBody>
-          <a:bodyPr wrap="square" rtlCol="0" anchor="ctr"/>
-          <a:lstStyle/>
-          <a:p>
-            <a:pPr indent="0" marL="0">
-              <a:buNone/>
-            </a:pPr>
-            <a:r>
-              <a:rPr lang="en-US" sz="1200" dirty="0">
+            <a:off x="7086600" y="3703320"/>
+            <a:ext cx="4160520" cy="640080"/>
+          </a:xfrm>
+          <a:prstGeom prst="rect">
+            <a:avLst/>
+          </a:prstGeom>
+          <a:noFill/>
+          <a:ln/>
+        </p:spPr>
+        <p:txBody>
+          <a:bodyPr wrap="square" rtlCol="0" anchor="ctr"/>
+          <a:lstStyle/>
+          <a:p>
+            <a:pPr indent="0" marL="0">
+              <a:lnSpc>
+                <a:spcPts val="1500"/>
+              </a:lnSpc>
+              <a:buNone/>
+            </a:pPr>
+            <a:r>
+              <a:rPr lang="en-US" sz="1150" dirty="0">
                 <a:solidFill>
                   <a:srgbClr val="9AB4A5"/>
                 </a:solidFill>
@@ -2538,7 +2544,7 @@
               </a:rPr>
               <a:t>Native support for international blind chess coordinate phonetics (Anna, Bella, Cesar, David...).</a:t>
             </a:r>
-            <a:endParaRPr lang="en-US" sz="1200" dirty="0"/>
+            <a:endParaRPr lang="en-US" sz="1150" dirty="0"/>
           </a:p>
         </p:txBody>
       </p:sp>
@@ -2550,12 +2556,12 @@
         </p:nvSpPr>
         <p:spPr>
           <a:xfrm>
-            <a:off x="6309360" y="4754880"/>
-            <a:ext cx="5120640" cy="1325880"/>
+            <a:off x="6263640" y="4617720"/>
+            <a:ext cx="5166360" cy="1371600"/>
           </a:xfrm>
           <a:prstGeom prst="roundRect">
             <a:avLst>
-              <a:gd name="adj" fmla="val 10345"/>
+              <a:gd name="adj" fmla="val 10000"/>
             </a:avLst>
           </a:prstGeom>
           <a:solidFill>
@@ -2591,7 +2597,7 @@
         </p:blipFill>
         <p:spPr>
           <a:xfrm>
-            <a:off x="6583680" y="5074920"/>
+            <a:off x="6537960" y="4937760"/>
             <a:ext cx="411480" cy="411480"/>
           </a:xfrm>
           <a:prstGeom prst="rect">
@@ -2607,8 +2613,8 @@
         </p:nvSpPr>
         <p:spPr>
           <a:xfrm>
-            <a:off x="7132320" y="4983480"/>
-            <a:ext cx="4023360" cy="320040"/>
+            <a:off x="7086600" y="4846320"/>
+            <a:ext cx="4160520" cy="320040"/>
           </a:xfrm>
           <a:prstGeom prst="rect">
             <a:avLst/>
@@ -2646,24 +2652,27 @@
         </p:nvSpPr>
         <p:spPr>
           <a:xfrm>
-            <a:off x="7132320" y="5349240"/>
-            <a:ext cx="4023360" cy="594360"/>
-          </a:xfrm>
-          <a:prstGeom prst="rect">
-            <a:avLst/>
-          </a:prstGeom>
-          <a:noFill/>
-          <a:ln/>
-        </p:spPr>
-        <p:txBody>
-          <a:bodyPr wrap="square" rtlCol="0" anchor="ctr"/>
-          <a:lstStyle/>
-          <a:p>
-            <a:pPr indent="0" marL="0">
-              <a:buNone/>
-            </a:pPr>
-            <a:r>
-              <a:rPr lang="en-US" sz="1200" dirty="0">
+            <a:off x="7086600" y="5212080"/>
+            <a:ext cx="4160520" cy="640080"/>
+          </a:xfrm>
+          <a:prstGeom prst="rect">
+            <a:avLst/>
+          </a:prstGeom>
+          <a:noFill/>
+          <a:ln/>
+        </p:spPr>
+        <p:txBody>
+          <a:bodyPr wrap="square" rtlCol="0" anchor="ctr"/>
+          <a:lstStyle/>
+          <a:p>
+            <a:pPr indent="0" marL="0">
+              <a:lnSpc>
+                <a:spcPts val="1500"/>
+              </a:lnSpc>
+              <a:buNone/>
+            </a:pPr>
+            <a:r>
+              <a:rPr lang="en-US" sz="1150" dirty="0">
                 <a:solidFill>
                   <a:srgbClr val="9AB4A5"/>
                 </a:solidFill>
@@ -2673,7 +2682,7 @@
               </a:rPr>
               <a:t>Full Bullet, Blitz, and Rapid timers with audio warnings and flag-fall detection.</a:t>
             </a:r>
-            <a:endParaRPr lang="en-US" sz="1200" dirty="0"/>
+            <a:endParaRPr lang="en-US" sz="1150" dirty="0"/>
           </a:p>
         </p:txBody>
       </p:sp>
@@ -2717,7 +2726,7 @@
         </p:nvSpPr>
         <p:spPr>
           <a:xfrm>
-            <a:off x="731520" y="457200"/>
+            <a:off x="731520" y="411480"/>
             <a:ext cx="2011680" cy="292608"/>
           </a:xfrm>
           <a:prstGeom prst="roundRect">
@@ -2744,7 +2753,7 @@
         </p:nvSpPr>
         <p:spPr>
           <a:xfrm>
-            <a:off x="731520" y="457200"/>
+            <a:off x="731520" y="411480"/>
             <a:ext cx="2011680" cy="292608"/>
           </a:xfrm>
           <a:prstGeom prst="rect">
@@ -2783,24 +2792,24 @@
         </p:nvSpPr>
         <p:spPr>
           <a:xfrm>
-            <a:off x="731520" y="822960"/>
-            <a:ext cx="10515600" cy="640080"/>
-          </a:xfrm>
-          <a:prstGeom prst="rect">
-            <a:avLst/>
-          </a:prstGeom>
-          <a:noFill/>
-          <a:ln/>
-        </p:spPr>
-        <p:txBody>
-          <a:bodyPr wrap="square" rtlCol="0" anchor="ctr"/>
-          <a:lstStyle/>
-          <a:p>
-            <a:pPr indent="0" marL="0">
-              <a:buNone/>
-            </a:pPr>
-            <a:r>
-              <a:rPr lang="en-US" sz="2400" b="1" dirty="0">
+            <a:off x="731520" y="777240"/>
+            <a:ext cx="10698480" cy="594360"/>
+          </a:xfrm>
+          <a:prstGeom prst="rect">
+            <a:avLst/>
+          </a:prstGeom>
+          <a:noFill/>
+          <a:ln/>
+        </p:spPr>
+        <p:txBody>
+          <a:bodyPr wrap="square" rtlCol="0" anchor="ctr"/>
+          <a:lstStyle/>
+          <a:p>
+            <a:pPr indent="0" marL="0">
+              <a:buNone/>
+            </a:pPr>
+            <a:r>
+              <a:rPr lang="en-US" sz="2200" b="1" dirty="0">
                 <a:solidFill>
                   <a:srgbClr val="E8F4EE"/>
                 </a:solidFill>
@@ -2810,7 +2819,7 @@
               </a:rPr>
               <a:t>Universal Accessibility: Engineered for Blind Players, Loved by All</a:t>
             </a:r>
-            <a:endParaRPr lang="en-US" sz="2400" dirty="0"/>
+            <a:endParaRPr lang="en-US" sz="2200" dirty="0"/>
           </a:p>
         </p:txBody>
       </p:sp>
@@ -2822,12 +2831,12 @@
         </p:nvSpPr>
         <p:spPr>
           <a:xfrm>
-            <a:off x="731520" y="1737360"/>
-            <a:ext cx="3429000" cy="4389120"/>
+            <a:off x="731520" y="1600200"/>
+            <a:ext cx="3337560" cy="4389120"/>
           </a:xfrm>
           <a:prstGeom prst="roundRect">
             <a:avLst>
-              <a:gd name="adj" fmla="val 4000"/>
+              <a:gd name="adj" fmla="val 4110"/>
             </a:avLst>
           </a:prstGeom>
           <a:solidFill>
@@ -2863,7 +2872,7 @@
         </p:blipFill>
         <p:spPr>
           <a:xfrm>
-            <a:off x="1097280" y="2103120"/>
+            <a:off x="1051560" y="1920240"/>
             <a:ext cx="457200" cy="457200"/>
           </a:xfrm>
           <a:prstGeom prst="rect">
@@ -2879,8 +2888,8 @@
         </p:nvSpPr>
         <p:spPr>
           <a:xfrm>
-            <a:off x="1097280" y="2743200"/>
-            <a:ext cx="2697480" cy="548640"/>
+            <a:off x="1051560" y="2560320"/>
+            <a:ext cx="2697480" cy="457200"/>
           </a:xfrm>
           <a:prstGeom prst="rect">
             <a:avLst/>
@@ -2904,7 +2913,7 @@
                 <a:ea typeface="Arial" pitchFamily="34" charset="-122"/>
                 <a:cs typeface="Arial" pitchFamily="34" charset="-120"/>
               </a:rPr>
-              <a:t>Blind &amp; Low-Vision Players</a:t>
+              <a:t>Blind &amp; Low-Vision</a:t>
             </a:r>
             <a:endParaRPr lang="en-US" sz="1600" dirty="0"/>
           </a:p>
@@ -2918,7 +2927,7 @@
         </p:nvSpPr>
         <p:spPr>
           <a:xfrm>
-            <a:off x="1097280" y="3383280"/>
+            <a:off x="1051560" y="3154680"/>
             <a:ext cx="2697480" cy="457200"/>
           </a:xfrm>
           <a:prstGeom prst="rect">
@@ -2935,7 +2944,7 @@
               <a:buNone/>
             </a:pPr>
             <a:r>
-              <a:rPr lang="en-US" sz="2400" b="1" dirty="0">
+              <a:rPr lang="en-US" sz="2200" b="1" dirty="0">
                 <a:solidFill>
                   <a:srgbClr val="5BA3F5"/>
                 </a:solidFill>
@@ -2945,7 +2954,7 @@
               </a:rPr>
               <a:t>285 Million</a:t>
             </a:r>
-            <a:endParaRPr lang="en-US" sz="2400" dirty="0"/>
+            <a:endParaRPr lang="en-US" sz="2200" dirty="0"/>
           </a:p>
         </p:txBody>
       </p:sp>
@@ -2957,7 +2966,7 @@
         </p:nvSpPr>
         <p:spPr>
           <a:xfrm>
-            <a:off x="1097280" y="3840480"/>
+            <a:off x="1051560" y="3611880"/>
             <a:ext cx="2697480" cy="274320"/>
           </a:xfrm>
           <a:prstGeom prst="rect">
@@ -2974,7 +2983,7 @@
               <a:buNone/>
             </a:pPr>
             <a:r>
-              <a:rPr lang="en-US" sz="1100" dirty="0">
+              <a:rPr lang="en-US" sz="1050" dirty="0">
                 <a:solidFill>
                   <a:srgbClr val="6E8A7B"/>
                 </a:solidFill>
@@ -2984,7 +2993,7 @@
               </a:rPr>
               <a:t>Visually impaired globally</a:t>
             </a:r>
-            <a:endParaRPr lang="en-US" sz="1100" dirty="0"/>
+            <a:endParaRPr lang="en-US" sz="1050" dirty="0"/>
           </a:p>
         </p:txBody>
       </p:sp>
@@ -2996,8 +3005,8 @@
         </p:nvSpPr>
         <p:spPr>
           <a:xfrm>
-            <a:off x="1097280" y="4206240"/>
-            <a:ext cx="2697480" cy="1645920"/>
+            <a:off x="1051560" y="4023360"/>
+            <a:ext cx="2697480" cy="1737360"/>
           </a:xfrm>
           <a:prstGeom prst="rect">
             <a:avLst/>
@@ -3038,12 +3047,12 @@
         </p:nvSpPr>
         <p:spPr>
           <a:xfrm>
-            <a:off x="4343400" y="1737360"/>
-            <a:ext cx="3429000" cy="4389120"/>
+            <a:off x="4416552" y="1600200"/>
+            <a:ext cx="3337560" cy="4389120"/>
           </a:xfrm>
           <a:prstGeom prst="roundRect">
             <a:avLst>
-              <a:gd name="adj" fmla="val 4000"/>
+              <a:gd name="adj" fmla="val 4110"/>
             </a:avLst>
           </a:prstGeom>
           <a:solidFill>
@@ -3079,7 +3088,7 @@
         </p:blipFill>
         <p:spPr>
           <a:xfrm>
-            <a:off x="4709160" y="2103120"/>
+            <a:off x="4736592" y="1920240"/>
             <a:ext cx="457200" cy="457200"/>
           </a:xfrm>
           <a:prstGeom prst="rect">
@@ -3095,8 +3104,8 @@
         </p:nvSpPr>
         <p:spPr>
           <a:xfrm>
-            <a:off x="4709160" y="2743200"/>
-            <a:ext cx="2697480" cy="548640"/>
+            <a:off x="4736592" y="2560320"/>
+            <a:ext cx="2697480" cy="457200"/>
           </a:xfrm>
           <a:prstGeom prst="rect">
             <a:avLst/>
@@ -3120,7 +3129,7 @@
                 <a:ea typeface="Arial" pitchFamily="34" charset="-122"/>
                 <a:cs typeface="Arial" pitchFamily="34" charset="-120"/>
               </a:rPr>
-              <a:t>Chess Students &amp; Learners</a:t>
+              <a:t>Chess Students</a:t>
             </a:r>
             <a:endParaRPr lang="en-US" sz="1600" dirty="0"/>
           </a:p>
@@ -3134,7 +3143,7 @@
         </p:nvSpPr>
         <p:spPr>
           <a:xfrm>
-            <a:off x="4709160" y="3383280"/>
+            <a:off x="4736592" y="3154680"/>
             <a:ext cx="2697480" cy="457200"/>
           </a:xfrm>
           <a:prstGeom prst="rect">
@@ -3151,7 +3160,7 @@
               <a:buNone/>
             </a:pPr>
             <a:r>
-              <a:rPr lang="en-US" sz="2400" b="1" dirty="0">
+              <a:rPr lang="en-US" sz="2200" b="1" dirty="0">
                 <a:solidFill>
                   <a:srgbClr val="5BA3F5"/>
                 </a:solidFill>
@@ -3161,7 +3170,7 @@
               </a:rPr>
               <a:t>600+ Million</a:t>
             </a:r>
-            <a:endParaRPr lang="en-US" sz="2400" dirty="0"/>
+            <a:endParaRPr lang="en-US" sz="2200" dirty="0"/>
           </a:p>
         </p:txBody>
       </p:sp>
@@ -3173,7 +3182,7 @@
         </p:nvSpPr>
         <p:spPr>
           <a:xfrm>
-            <a:off x="4709160" y="3840480"/>
+            <a:off x="4736592" y="3611880"/>
             <a:ext cx="2697480" cy="274320"/>
           </a:xfrm>
           <a:prstGeom prst="rect">
@@ -3190,7 +3199,7 @@
               <a:buNone/>
             </a:pPr>
             <a:r>
-              <a:rPr lang="en-US" sz="1100" dirty="0">
+              <a:rPr lang="en-US" sz="1050" dirty="0">
                 <a:solidFill>
                   <a:srgbClr val="6E8A7B"/>
                 </a:solidFill>
@@ -3200,7 +3209,7 @@
               </a:rPr>
               <a:t>Active chess players worldwide</a:t>
             </a:r>
-            <a:endParaRPr lang="en-US" sz="1100" dirty="0"/>
+            <a:endParaRPr lang="en-US" sz="1050" dirty="0"/>
           </a:p>
         </p:txBody>
       </p:sp>
@@ -3212,8 +3221,8 @@
         </p:nvSpPr>
         <p:spPr>
           <a:xfrm>
-            <a:off x="4709160" y="4206240"/>
-            <a:ext cx="2697480" cy="1645920"/>
+            <a:off x="4736592" y="4023360"/>
+            <a:ext cx="2697480" cy="1737360"/>
           </a:xfrm>
           <a:prstGeom prst="rect">
             <a:avLst/>
@@ -3254,12 +3263,12 @@
         </p:nvSpPr>
         <p:spPr>
           <a:xfrm>
-            <a:off x="7955280" y="1737360"/>
-            <a:ext cx="3429000" cy="4389120"/>
+            <a:off x="8101584" y="1600200"/>
+            <a:ext cx="3337560" cy="4389120"/>
           </a:xfrm>
           <a:prstGeom prst="roundRect">
             <a:avLst>
-              <a:gd name="adj" fmla="val 4000"/>
+              <a:gd name="adj" fmla="val 4110"/>
             </a:avLst>
           </a:prstGeom>
           <a:solidFill>
@@ -3295,7 +3304,7 @@
         </p:blipFill>
         <p:spPr>
           <a:xfrm>
-            <a:off x="8321040" y="2103120"/>
+            <a:off x="8421624" y="1920240"/>
             <a:ext cx="457200" cy="457200"/>
           </a:xfrm>
           <a:prstGeom prst="rect">
@@ -3311,8 +3320,8 @@
         </p:nvSpPr>
         <p:spPr>
           <a:xfrm>
-            <a:off x="8321040" y="2743200"/>
-            <a:ext cx="2697480" cy="548640"/>
+            <a:off x="8421624" y="2560320"/>
+            <a:ext cx="2697480" cy="457200"/>
           </a:xfrm>
           <a:prstGeom prst="rect">
             <a:avLst/>
@@ -3336,7 +3345,7 @@
                 <a:ea typeface="Arial" pitchFamily="34" charset="-122"/>
                 <a:cs typeface="Arial" pitchFamily="34" charset="-120"/>
               </a:rPr>
-              <a:t>Hands-Free &amp; Commuter Players</a:t>
+              <a:t>Commuter Players</a:t>
             </a:r>
             <a:endParaRPr lang="en-US" sz="1600" dirty="0"/>
           </a:p>
@@ -3350,7 +3359,7 @@
         </p:nvSpPr>
         <p:spPr>
           <a:xfrm>
-            <a:off x="8321040" y="3383280"/>
+            <a:off x="8421624" y="3154680"/>
             <a:ext cx="2697480" cy="457200"/>
           </a:xfrm>
           <a:prstGeom prst="rect">
@@ -3367,7 +3376,7 @@
               <a:buNone/>
             </a:pPr>
             <a:r>
-              <a:rPr lang="en-US" sz="2400" b="1" dirty="0">
+              <a:rPr lang="en-US" sz="2200" b="1" dirty="0">
                 <a:solidFill>
                   <a:srgbClr val="5BA3F5"/>
                 </a:solidFill>
@@ -3377,7 +3386,7 @@
               </a:rPr>
               <a:t>10+ Million</a:t>
             </a:r>
-            <a:endParaRPr lang="en-US" sz="2400" dirty="0"/>
+            <a:endParaRPr lang="en-US" sz="2200" dirty="0"/>
           </a:p>
         </p:txBody>
       </p:sp>
@@ -3389,7 +3398,7 @@
         </p:nvSpPr>
         <p:spPr>
           <a:xfrm>
-            <a:off x="8321040" y="3840480"/>
+            <a:off x="8421624" y="3611880"/>
             <a:ext cx="2697480" cy="274320"/>
           </a:xfrm>
           <a:prstGeom prst="rect">
@@ -3406,7 +3415,7 @@
               <a:buNone/>
             </a:pPr>
             <a:r>
-              <a:rPr lang="en-US" sz="1100" dirty="0">
+              <a:rPr lang="en-US" sz="1050" dirty="0">
                 <a:solidFill>
                   <a:srgbClr val="6E8A7B"/>
                 </a:solidFill>
@@ -3414,9 +3423,9 @@
                 <a:ea typeface="Arial" pitchFamily="34" charset="-122"/>
                 <a:cs typeface="Arial" pitchFamily="34" charset="-120"/>
               </a:rPr>
-              <a:t>Mobile audio entertainment market</a:t>
-            </a:r>
-            <a:endParaRPr lang="en-US" sz="1100" dirty="0"/>
+              <a:t>Mobile audio gaming segment</a:t>
+            </a:r>
+            <a:endParaRPr lang="en-US" sz="1050" dirty="0"/>
           </a:p>
         </p:txBody>
       </p:sp>
@@ -3428,8 +3437,8 @@
         </p:nvSpPr>
         <p:spPr>
           <a:xfrm>
-            <a:off x="8321040" y="4206240"/>
-            <a:ext cx="2697480" cy="1645920"/>
+            <a:off x="8421624" y="4023360"/>
+            <a:ext cx="2697480" cy="1737360"/>
           </a:xfrm>
           <a:prstGeom prst="rect">
             <a:avLst/>
@@ -3502,7 +3511,7 @@
         </p:nvSpPr>
         <p:spPr>
           <a:xfrm>
-            <a:off x="731520" y="457200"/>
+            <a:off x="731520" y="411480"/>
             <a:ext cx="2011680" cy="292608"/>
           </a:xfrm>
           <a:prstGeom prst="roundRect">
@@ -3529,7 +3538,7 @@
         </p:nvSpPr>
         <p:spPr>
           <a:xfrm>
-            <a:off x="731520" y="457200"/>
+            <a:off x="731520" y="411480"/>
             <a:ext cx="2011680" cy="292608"/>
           </a:xfrm>
           <a:prstGeom prst="rect">
@@ -3568,24 +3577,24 @@
         </p:nvSpPr>
         <p:spPr>
           <a:xfrm>
-            <a:off x="731520" y="822960"/>
-            <a:ext cx="10515600" cy="640080"/>
-          </a:xfrm>
-          <a:prstGeom prst="rect">
-            <a:avLst/>
-          </a:prstGeom>
-          <a:noFill/>
-          <a:ln/>
-        </p:spPr>
-        <p:txBody>
-          <a:bodyPr wrap="square" rtlCol="0" anchor="ctr"/>
-          <a:lstStyle/>
-          <a:p>
-            <a:pPr indent="0" marL="0">
-              <a:buNone/>
-            </a:pPr>
-            <a:r>
-              <a:rPr lang="en-US" sz="2400" b="1" dirty="0">
+            <a:off x="731520" y="777240"/>
+            <a:ext cx="10698480" cy="594360"/>
+          </a:xfrm>
+          <a:prstGeom prst="rect">
+            <a:avLst/>
+          </a:prstGeom>
+          <a:noFill/>
+          <a:ln/>
+        </p:spPr>
+        <p:txBody>
+          <a:bodyPr wrap="square" rtlCol="0" anchor="ctr"/>
+          <a:lstStyle/>
+          <a:p>
+            <a:pPr indent="0" marL="0">
+              <a:buNone/>
+            </a:pPr>
+            <a:r>
+              <a:rPr lang="en-US" sz="2200" b="1" dirty="0">
                 <a:solidFill>
                   <a:srgbClr val="E8F4EE"/>
                 </a:solidFill>
@@ -3595,7 +3604,7 @@
               </a:rPr>
               <a:t>Robust Full-Stack Pipeline with Guaranteed Audio Delivery</a:t>
             </a:r>
-            <a:endParaRPr lang="en-US" sz="2400" dirty="0"/>
+            <a:endParaRPr lang="en-US" sz="2200" dirty="0"/>
           </a:p>
         </p:txBody>
       </p:sp>
@@ -3607,12 +3616,12 @@
         </p:nvSpPr>
         <p:spPr>
           <a:xfrm>
-            <a:off x="731520" y="1737360"/>
-            <a:ext cx="3429000" cy="4389120"/>
+            <a:off x="731520" y="1600200"/>
+            <a:ext cx="3337560" cy="4389120"/>
           </a:xfrm>
           <a:prstGeom prst="roundRect">
             <a:avLst>
-              <a:gd name="adj" fmla="val 4000"/>
+              <a:gd name="adj" fmla="val 4110"/>
             </a:avLst>
           </a:prstGeom>
           <a:solidFill>
@@ -3648,7 +3657,7 @@
         </p:blipFill>
         <p:spPr>
           <a:xfrm>
-            <a:off x="1097280" y="2103120"/>
+            <a:off x="1051560" y="1920240"/>
             <a:ext cx="411480" cy="411480"/>
           </a:xfrm>
           <a:prstGeom prst="rect">
@@ -3664,7 +3673,7 @@
         </p:nvSpPr>
         <p:spPr>
           <a:xfrm>
-            <a:off x="1097280" y="2651760"/>
+            <a:off x="1051560" y="2468880"/>
             <a:ext cx="2697480" cy="548640"/>
           </a:xfrm>
           <a:prstGeom prst="rect">
@@ -3681,7 +3690,7 @@
               <a:buNone/>
             </a:pPr>
             <a:r>
-              <a:rPr lang="en-US" sz="1600" b="1" dirty="0">
+              <a:rPr lang="en-US" sz="1500" b="1" dirty="0">
                 <a:solidFill>
                   <a:srgbClr val="FFFFFF"/>
                 </a:solidFill>
@@ -3691,7 +3700,7 @@
               </a:rPr>
               <a:t>AssemblyAI Voice Agent</a:t>
             </a:r>
-            <a:endParaRPr lang="en-US" sz="1600" dirty="0"/>
+            <a:endParaRPr lang="en-US" sz="1500" dirty="0"/>
           </a:p>
         </p:txBody>
       </p:sp>
@@ -3703,8 +3712,8 @@
         </p:nvSpPr>
         <p:spPr>
           <a:xfrm>
-            <a:off x="1097280" y="3291840"/>
-            <a:ext cx="2697480" cy="2560320"/>
+            <a:off x="1051560" y="3108960"/>
+            <a:ext cx="2697480" cy="2651760"/>
           </a:xfrm>
           <a:prstGeom prst="rect">
             <a:avLst/>
@@ -3718,12 +3727,12 @@
           <a:p>
             <a:pPr indent="0" marL="0">
               <a:lnSpc>
-                <a:spcPts val="1800"/>
+                <a:spcPts val="1600"/>
               </a:lnSpc>
               <a:buNone/>
             </a:pPr>
             <a:r>
-              <a:rPr lang="en-US" sz="1200" dirty="0">
+              <a:rPr lang="en-US" sz="1150" dirty="0">
                 <a:solidFill>
                   <a:srgbClr val="9AB4A5"/>
                 </a:solidFill>
@@ -3733,26 +3742,26 @@
               </a:rPr>
               <a:t>• Direct WebSocket streaming with sub-300ms turn-around.</a:t>
             </a:r>
-            <a:endParaRPr lang="en-US" sz="1200" dirty="0"/>
+            <a:endParaRPr lang="en-US" sz="1150" dirty="0"/>
           </a:p>
           <a:p>
             <a:pPr indent="0" marL="0">
               <a:lnSpc>
-                <a:spcPts val="1800"/>
+                <a:spcPts val="1600"/>
               </a:lnSpc>
               <a:buNone/>
             </a:pPr>
-            <a:endParaRPr lang="en-US" sz="1200" dirty="0"/>
+            <a:endParaRPr lang="en-US" sz="1150" dirty="0"/>
           </a:p>
           <a:p>
             <a:pPr indent="0" marL="0">
               <a:lnSpc>
-                <a:spcPts val="1800"/>
+                <a:spcPts val="1600"/>
               </a:lnSpc>
               <a:buNone/>
             </a:pPr>
             <a:r>
-              <a:rPr lang="en-US" sz="1200" dirty="0">
+              <a:rPr lang="en-US" sz="1150" dirty="0">
                 <a:solidFill>
                   <a:srgbClr val="9AB4A5"/>
                 </a:solidFill>
@@ -3762,26 +3771,26 @@
               </a:rPr>
               <a:t>• AudioWorklet captures 24kHz PCM16 in 25ms chunks.</a:t>
             </a:r>
-            <a:endParaRPr lang="en-US" sz="1200" dirty="0"/>
+            <a:endParaRPr lang="en-US" sz="1150" dirty="0"/>
           </a:p>
           <a:p>
             <a:pPr indent="0" marL="0">
               <a:lnSpc>
-                <a:spcPts val="1800"/>
+                <a:spcPts val="1600"/>
               </a:lnSpc>
               <a:buNone/>
             </a:pPr>
-            <a:endParaRPr lang="en-US" sz="1200" dirty="0"/>
+            <a:endParaRPr lang="en-US" sz="1150" dirty="0"/>
           </a:p>
           <a:p>
             <a:pPr indent="0" marL="0">
               <a:lnSpc>
-                <a:spcPts val="1800"/>
+                <a:spcPts val="1600"/>
               </a:lnSpc>
               <a:buNone/>
             </a:pPr>
             <a:r>
-              <a:rPr lang="en-US" sz="1200" dirty="0">
+              <a:rPr lang="en-US" sz="1150" dirty="0">
                 <a:solidFill>
                   <a:srgbClr val="9AB4A5"/>
                 </a:solidFill>
@@ -3791,26 +3800,26 @@
               </a:rPr>
               <a:t>• Context-aware language parsing with chess keyterms.</a:t>
             </a:r>
-            <a:endParaRPr lang="en-US" sz="1200" dirty="0"/>
+            <a:endParaRPr lang="en-US" sz="1150" dirty="0"/>
           </a:p>
           <a:p>
             <a:pPr indent="0" marL="0">
               <a:lnSpc>
-                <a:spcPts val="1800"/>
+                <a:spcPts val="1600"/>
               </a:lnSpc>
               <a:buNone/>
             </a:pPr>
-            <a:endParaRPr lang="en-US" sz="1200" dirty="0"/>
+            <a:endParaRPr lang="en-US" sz="1150" dirty="0"/>
           </a:p>
           <a:p>
             <a:pPr indent="0" marL="0">
               <a:lnSpc>
-                <a:spcPts val="1800"/>
+                <a:spcPts val="1600"/>
               </a:lnSpc>
               <a:buNone/>
             </a:pPr>
             <a:r>
-              <a:rPr lang="en-US" sz="1200" dirty="0">
+              <a:rPr lang="en-US" sz="1150" dirty="0">
                 <a:solidFill>
                   <a:srgbClr val="9AB4A5"/>
                 </a:solidFill>
@@ -3820,7 +3829,7 @@
               </a:rPr>
               <a:t>• Deterministic tool calls: apply_move, describe_board.</a:t>
             </a:r>
-            <a:endParaRPr lang="en-US" sz="1200" dirty="0"/>
+            <a:endParaRPr lang="en-US" sz="1150" dirty="0"/>
           </a:p>
         </p:txBody>
       </p:sp>
@@ -3832,12 +3841,12 @@
         </p:nvSpPr>
         <p:spPr>
           <a:xfrm>
-            <a:off x="4343400" y="1737360"/>
-            <a:ext cx="3429000" cy="4389120"/>
+            <a:off x="4416552" y="1600200"/>
+            <a:ext cx="3337560" cy="4389120"/>
           </a:xfrm>
           <a:prstGeom prst="roundRect">
             <a:avLst>
-              <a:gd name="adj" fmla="val 4000"/>
+              <a:gd name="adj" fmla="val 4110"/>
             </a:avLst>
           </a:prstGeom>
           <a:solidFill>
@@ -3873,7 +3882,7 @@
         </p:blipFill>
         <p:spPr>
           <a:xfrm>
-            <a:off x="4709160" y="2103120"/>
+            <a:off x="4736592" y="1920240"/>
             <a:ext cx="411480" cy="411480"/>
           </a:xfrm>
           <a:prstGeom prst="rect">
@@ -3889,7 +3898,7 @@
         </p:nvSpPr>
         <p:spPr>
           <a:xfrm>
-            <a:off x="4709160" y="2651760"/>
+            <a:off x="4736592" y="2468880"/>
             <a:ext cx="2697480" cy="548640"/>
           </a:xfrm>
           <a:prstGeom prst="rect">
@@ -3906,7 +3915,7 @@
               <a:buNone/>
             </a:pPr>
             <a:r>
-              <a:rPr lang="en-US" sz="1600" b="1" dirty="0">
+              <a:rPr lang="en-US" sz="1500" b="1" dirty="0">
                 <a:solidFill>
                   <a:srgbClr val="FFFFFF"/>
                 </a:solidFill>
@@ -3916,7 +3925,7 @@
               </a:rPr>
               <a:t>Dual AudioContext Engine</a:t>
             </a:r>
-            <a:endParaRPr lang="en-US" sz="1600" dirty="0"/>
+            <a:endParaRPr lang="en-US" sz="1500" dirty="0"/>
           </a:p>
         </p:txBody>
       </p:sp>
@@ -3928,8 +3937,8 @@
         </p:nvSpPr>
         <p:spPr>
           <a:xfrm>
-            <a:off x="4709160" y="3291840"/>
-            <a:ext cx="2697480" cy="2560320"/>
+            <a:off x="4736592" y="3108960"/>
+            <a:ext cx="2697480" cy="2651760"/>
           </a:xfrm>
           <a:prstGeom prst="rect">
             <a:avLst/>
@@ -3943,12 +3952,12 @@
           <a:p>
             <a:pPr indent="0" marL="0">
               <a:lnSpc>
-                <a:spcPts val="1800"/>
+                <a:spcPts val="1600"/>
               </a:lnSpc>
               <a:buNone/>
             </a:pPr>
             <a:r>
-              <a:rPr lang="en-US" sz="1200" dirty="0">
+              <a:rPr lang="en-US" sz="1150" dirty="0">
                 <a:solidFill>
                   <a:srgbClr val="9AB4A5"/>
                 </a:solidFill>
@@ -3958,26 +3967,26 @@
               </a:rPr>
               <a:t>• Linux/PulseAudio solved: 48kHz output + 24kHz capture.</a:t>
             </a:r>
-            <a:endParaRPr lang="en-US" sz="1200" dirty="0"/>
+            <a:endParaRPr lang="en-US" sz="1150" dirty="0"/>
           </a:p>
           <a:p>
             <a:pPr indent="0" marL="0">
               <a:lnSpc>
-                <a:spcPts val="1800"/>
+                <a:spcPts val="1600"/>
               </a:lnSpc>
               <a:buNone/>
             </a:pPr>
-            <a:endParaRPr lang="en-US" sz="1200" dirty="0"/>
+            <a:endParaRPr lang="en-US" sz="1150" dirty="0"/>
           </a:p>
           <a:p>
             <a:pPr indent="0" marL="0">
               <a:lnSpc>
-                <a:spcPts val="1800"/>
+                <a:spcPts val="1600"/>
               </a:lnSpc>
               <a:buNone/>
             </a:pPr>
             <a:r>
-              <a:rPr lang="en-US" sz="1200" dirty="0">
+              <a:rPr lang="en-US" sz="1150" dirty="0">
                 <a:solidFill>
                   <a:srgbClr val="9AB4A5"/>
                 </a:solidFill>
@@ -3987,26 +3996,26 @@
               </a:rPr>
               <a:t>• No silent clipping or buffer dropouts.</a:t>
             </a:r>
-            <a:endParaRPr lang="en-US" sz="1200" dirty="0"/>
+            <a:endParaRPr lang="en-US" sz="1150" dirty="0"/>
           </a:p>
           <a:p>
             <a:pPr indent="0" marL="0">
               <a:lnSpc>
-                <a:spcPts val="1800"/>
+                <a:spcPts val="1600"/>
               </a:lnSpc>
               <a:buNone/>
             </a:pPr>
-            <a:endParaRPr lang="en-US" sz="1200" dirty="0"/>
+            <a:endParaRPr lang="en-US" sz="1150" dirty="0"/>
           </a:p>
           <a:p>
             <a:pPr indent="0" marL="0">
               <a:lnSpc>
-                <a:spcPts val="1800"/>
+                <a:spcPts val="1600"/>
               </a:lnSpc>
               <a:buNone/>
             </a:pPr>
             <a:r>
-              <a:rPr lang="en-US" sz="1200" dirty="0">
+              <a:rPr lang="en-US" sz="1150" dirty="0">
                 <a:solidFill>
                   <a:srgbClr val="9AB4A5"/>
                 </a:solidFill>
@@ -4016,26 +4025,26 @@
               </a:rPr>
               <a:t>• AudioBufferSourceNode zero-latency playback queue.</a:t>
             </a:r>
-            <a:endParaRPr lang="en-US" sz="1200" dirty="0"/>
+            <a:endParaRPr lang="en-US" sz="1150" dirty="0"/>
           </a:p>
           <a:p>
             <a:pPr indent="0" marL="0">
               <a:lnSpc>
-                <a:spcPts val="1800"/>
+                <a:spcPts val="1600"/>
               </a:lnSpc>
               <a:buNone/>
             </a:pPr>
-            <a:endParaRPr lang="en-US" sz="1200" dirty="0"/>
+            <a:endParaRPr lang="en-US" sz="1150" dirty="0"/>
           </a:p>
           <a:p>
             <a:pPr indent="0" marL="0">
               <a:lnSpc>
-                <a:spcPts val="1800"/>
+                <a:spcPts val="1600"/>
               </a:lnSpc>
               <a:buNone/>
             </a:pPr>
             <a:r>
-              <a:rPr lang="en-US" sz="1200" dirty="0">
+              <a:rPr lang="en-US" sz="1150" dirty="0">
                 <a:solidFill>
                   <a:srgbClr val="9AB4A5"/>
                 </a:solidFill>
@@ -4045,7 +4054,7 @@
               </a:rPr>
               <a:t>• Web Audio synthesized chess.com wood sound acoustics.</a:t>
             </a:r>
-            <a:endParaRPr lang="en-US" sz="1200" dirty="0"/>
+            <a:endParaRPr lang="en-US" sz="1150" dirty="0"/>
           </a:p>
         </p:txBody>
       </p:sp>
@@ -4057,12 +4066,12 @@
         </p:nvSpPr>
         <p:spPr>
           <a:xfrm>
-            <a:off x="7955280" y="1737360"/>
-            <a:ext cx="3429000" cy="4389120"/>
+            <a:off x="8101584" y="1600200"/>
+            <a:ext cx="3337560" cy="4389120"/>
           </a:xfrm>
           <a:prstGeom prst="roundRect">
             <a:avLst>
-              <a:gd name="adj" fmla="val 4000"/>
+              <a:gd name="adj" fmla="val 4110"/>
             </a:avLst>
           </a:prstGeom>
           <a:solidFill>
@@ -4098,7 +4107,7 @@
         </p:blipFill>
         <p:spPr>
           <a:xfrm>
-            <a:off x="8321040" y="2103120"/>
+            <a:off x="8421624" y="1920240"/>
             <a:ext cx="411480" cy="411480"/>
           </a:xfrm>
           <a:prstGeom prst="rect">
@@ -4114,7 +4123,7 @@
         </p:nvSpPr>
         <p:spPr>
           <a:xfrm>
-            <a:off x="8321040" y="2651760"/>
+            <a:off x="8421624" y="2468880"/>
             <a:ext cx="2697480" cy="548640"/>
           </a:xfrm>
           <a:prstGeom prst="rect">
@@ -4131,7 +4140,7 @@
               <a:buNone/>
             </a:pPr>
             <a:r>
-              <a:rPr lang="en-US" sz="1600" b="1" dirty="0">
+              <a:rPr lang="en-US" sz="1500" b="1" dirty="0">
                 <a:solidFill>
                   <a:srgbClr val="FFFFFF"/>
                 </a:solidFill>
@@ -4141,7 +4150,7 @@
               </a:rPr>
               <a:t>Deterministic Chess Core</a:t>
             </a:r>
-            <a:endParaRPr lang="en-US" sz="1600" dirty="0"/>
+            <a:endParaRPr lang="en-US" sz="1500" dirty="0"/>
           </a:p>
         </p:txBody>
       </p:sp>
@@ -4153,8 +4162,8 @@
         </p:nvSpPr>
         <p:spPr>
           <a:xfrm>
-            <a:off x="8321040" y="3291840"/>
-            <a:ext cx="2697480" cy="2560320"/>
+            <a:off x="8421624" y="3108960"/>
+            <a:ext cx="2697480" cy="2651760"/>
           </a:xfrm>
           <a:prstGeom prst="rect">
             <a:avLst/>
@@ -4168,12 +4177,12 @@
           <a:p>
             <a:pPr indent="0" marL="0">
               <a:lnSpc>
-                <a:spcPts val="1800"/>
+                <a:spcPts val="1600"/>
               </a:lnSpc>
               <a:buNone/>
             </a:pPr>
             <a:r>
-              <a:rPr lang="en-US" sz="1200" dirty="0">
+              <a:rPr lang="en-US" sz="1150" dirty="0">
                 <a:solidFill>
                   <a:srgbClr val="9AB4A5"/>
                 </a:solidFill>
@@ -4183,26 +4192,26 @@
               </a:rPr>
               <a:t>• chess.js integration with complete legal move validation.</a:t>
             </a:r>
-            <a:endParaRPr lang="en-US" sz="1200" dirty="0"/>
+            <a:endParaRPr lang="en-US" sz="1150" dirty="0"/>
           </a:p>
           <a:p>
             <a:pPr indent="0" marL="0">
               <a:lnSpc>
-                <a:spcPts val="1800"/>
+                <a:spcPts val="1600"/>
               </a:lnSpc>
               <a:buNone/>
             </a:pPr>
-            <a:endParaRPr lang="en-US" sz="1200" dirty="0"/>
+            <a:endParaRPr lang="en-US" sz="1150" dirty="0"/>
           </a:p>
           <a:p>
             <a:pPr indent="0" marL="0">
               <a:lnSpc>
-                <a:spcPts val="1800"/>
+                <a:spcPts val="1600"/>
               </a:lnSpc>
               <a:buNone/>
             </a:pPr>
             <a:r>
-              <a:rPr lang="en-US" sz="1200" dirty="0">
+              <a:rPr lang="en-US" sz="1150" dirty="0">
                 <a:solidFill>
                   <a:srgbClr val="9AB4A5"/>
                 </a:solidFill>
@@ -4212,26 +4221,26 @@
               </a:rPr>
               <a:t>• Stockfish 16 WASM AI opponent with 4 difficulty levels.</a:t>
             </a:r>
-            <a:endParaRPr lang="en-US" sz="1200" dirty="0"/>
+            <a:endParaRPr lang="en-US" sz="1150" dirty="0"/>
           </a:p>
           <a:p>
             <a:pPr indent="0" marL="0">
               <a:lnSpc>
-                <a:spcPts val="1800"/>
+                <a:spcPts val="1600"/>
               </a:lnSpc>
               <a:buNone/>
             </a:pPr>
-            <a:endParaRPr lang="en-US" sz="1200" dirty="0"/>
+            <a:endParaRPr lang="en-US" sz="1150" dirty="0"/>
           </a:p>
           <a:p>
             <a:pPr indent="0" marL="0">
               <a:lnSpc>
-                <a:spcPts val="1800"/>
+                <a:spcPts val="1600"/>
               </a:lnSpc>
               <a:buNone/>
             </a:pPr>
             <a:r>
-              <a:rPr lang="en-US" sz="1200" dirty="0">
+              <a:rPr lang="en-US" sz="1150" dirty="0">
                 <a:solidFill>
                   <a:srgbClr val="9AB4A5"/>
                 </a:solidFill>
@@ -4239,28 +4248,28 @@
                 <a:ea typeface="Arial" pitchFamily="34" charset="-122"/>
                 <a:cs typeface="Arial" pitchFamily="34" charset="-120"/>
               </a:rPr>
-              <a:t>• 337 automated Vitest unit &amp; adversarial tests in CI.</a:t>
-            </a:r>
-            <a:endParaRPr lang="en-US" sz="1200" dirty="0"/>
+              <a:t>• 335 automated Vitest unit &amp; adversarial tests in CI.</a:t>
+            </a:r>
+            <a:endParaRPr lang="en-US" sz="1150" dirty="0"/>
           </a:p>
           <a:p>
             <a:pPr indent="0" marL="0">
               <a:lnSpc>
-                <a:spcPts val="1800"/>
+                <a:spcPts val="1600"/>
               </a:lnSpc>
               <a:buNone/>
             </a:pPr>
-            <a:endParaRPr lang="en-US" sz="1200" dirty="0"/>
+            <a:endParaRPr lang="en-US" sz="1150" dirty="0"/>
           </a:p>
           <a:p>
             <a:pPr indent="0" marL="0">
               <a:lnSpc>
-                <a:spcPts val="1800"/>
+                <a:spcPts val="1600"/>
               </a:lnSpc>
               <a:buNone/>
             </a:pPr>
             <a:r>
-              <a:rPr lang="en-US" sz="1200" dirty="0">
+              <a:rPr lang="en-US" sz="1150" dirty="0">
                 <a:solidFill>
                   <a:srgbClr val="9AB4A5"/>
                 </a:solidFill>
@@ -4270,7 +4279,7 @@
               </a:rPr>
               <a:t>• Full state persistence across network reconnects.</a:t>
             </a:r>
-            <a:endParaRPr lang="en-US" sz="1200" dirty="0"/>
+            <a:endParaRPr lang="en-US" sz="1150" dirty="0"/>
           </a:p>
         </p:txBody>
       </p:sp>
@@ -4314,7 +4323,7 @@
         </p:nvSpPr>
         <p:spPr>
           <a:xfrm>
-            <a:off x="731520" y="457200"/>
+            <a:off x="731520" y="411480"/>
             <a:ext cx="2011680" cy="292608"/>
           </a:xfrm>
           <a:prstGeom prst="roundRect">
@@ -4341,7 +4350,7 @@
         </p:nvSpPr>
         <p:spPr>
           <a:xfrm>
-            <a:off x="731520" y="457200"/>
+            <a:off x="731520" y="411480"/>
             <a:ext cx="2011680" cy="292608"/>
           </a:xfrm>
           <a:prstGeom prst="rect">
@@ -4380,24 +4389,24 @@
         </p:nvSpPr>
         <p:spPr>
           <a:xfrm>
-            <a:off x="731520" y="822960"/>
-            <a:ext cx="10515600" cy="640080"/>
-          </a:xfrm>
-          <a:prstGeom prst="rect">
-            <a:avLst/>
-          </a:prstGeom>
-          <a:noFill/>
-          <a:ln/>
-        </p:spPr>
-        <p:txBody>
-          <a:bodyPr wrap="square" rtlCol="0" anchor="ctr"/>
-          <a:lstStyle/>
-          <a:p>
-            <a:pPr indent="0" marL="0">
-              <a:buNone/>
-            </a:pPr>
-            <a:r>
-              <a:rPr lang="en-US" sz="2400" b="1" dirty="0">
+            <a:off x="731520" y="777240"/>
+            <a:ext cx="10698480" cy="594360"/>
+          </a:xfrm>
+          <a:prstGeom prst="rect">
+            <a:avLst/>
+          </a:prstGeom>
+          <a:noFill/>
+          <a:ln/>
+        </p:spPr>
+        <p:txBody>
+          <a:bodyPr wrap="square" rtlCol="0" anchor="ctr"/>
+          <a:lstStyle/>
+          <a:p>
+            <a:pPr indent="0" marL="0">
+              <a:buNone/>
+            </a:pPr>
+            <a:r>
+              <a:rPr lang="en-US" sz="2200" b="1" dirty="0">
                 <a:solidFill>
                   <a:srgbClr val="E8F4EE"/>
                 </a:solidFill>
@@ -4407,7 +4416,7 @@
               </a:rPr>
               <a:t>Uncontested Category: Voice-First Accessible Digital Chess</a:t>
             </a:r>
-            <a:endParaRPr lang="en-US" sz="2400" dirty="0"/>
+            <a:endParaRPr lang="en-US" sz="2200" dirty="0"/>
           </a:p>
         </p:txBody>
       </p:sp>
@@ -4419,8 +4428,8 @@
         </p:nvSpPr>
         <p:spPr>
           <a:xfrm>
-            <a:off x="731520" y="1737360"/>
-            <a:ext cx="5120640" cy="4389120"/>
+            <a:off x="731520" y="1600200"/>
+            <a:ext cx="5166360" cy="4389120"/>
           </a:xfrm>
           <a:prstGeom prst="roundRect">
             <a:avLst>
@@ -4460,8 +4469,8 @@
         </p:blipFill>
         <p:spPr>
           <a:xfrm>
-            <a:off x="1097280" y="2103120"/>
-            <a:ext cx="457200" cy="457200"/>
+            <a:off x="1051560" y="1920240"/>
+            <a:ext cx="411480" cy="411480"/>
           </a:xfrm>
           <a:prstGeom prst="rect">
             <a:avLst/>
@@ -4476,24 +4485,24 @@
         </p:nvSpPr>
         <p:spPr>
           <a:xfrm>
-            <a:off x="1645920" y="2148840"/>
-            <a:ext cx="3840480" cy="365760"/>
-          </a:xfrm>
-          <a:prstGeom prst="rect">
-            <a:avLst/>
-          </a:prstGeom>
-          <a:noFill/>
-          <a:ln/>
-        </p:spPr>
-        <p:txBody>
-          <a:bodyPr wrap="square" rtlCol="0" anchor="ctr"/>
-          <a:lstStyle/>
-          <a:p>
-            <a:pPr indent="0" marL="0">
-              <a:buNone/>
-            </a:pPr>
-            <a:r>
-              <a:rPr lang="en-US" sz="1800" b="1" dirty="0">
+            <a:off x="1600200" y="1965960"/>
+            <a:ext cx="4160520" cy="365760"/>
+          </a:xfrm>
+          <a:prstGeom prst="rect">
+            <a:avLst/>
+          </a:prstGeom>
+          <a:noFill/>
+          <a:ln/>
+        </p:spPr>
+        <p:txBody>
+          <a:bodyPr wrap="square" rtlCol="0" anchor="ctr"/>
+          <a:lstStyle/>
+          <a:p>
+            <a:pPr indent="0" marL="0">
+              <a:buNone/>
+            </a:pPr>
+            <a:r>
+              <a:rPr lang="en-US" sz="1700" b="1" dirty="0">
                 <a:solidFill>
                   <a:srgbClr val="FFFFFF"/>
                 </a:solidFill>
@@ -4503,7 +4512,7 @@
               </a:rPr>
               <a:t>Market Size &amp; Opportunity</a:t>
             </a:r>
-            <a:endParaRPr lang="en-US" sz="1800" dirty="0"/>
+            <a:endParaRPr lang="en-US" sz="1700" dirty="0"/>
           </a:p>
         </p:txBody>
       </p:sp>
@@ -4515,8 +4524,8 @@
         </p:nvSpPr>
         <p:spPr>
           <a:xfrm>
-            <a:off x="1097280" y="2743200"/>
-            <a:ext cx="4389120" cy="3108960"/>
+            <a:off x="1051560" y="2560320"/>
+            <a:ext cx="4526280" cy="3108960"/>
           </a:xfrm>
           <a:prstGeom prst="rect">
             <a:avLst/>
@@ -4530,12 +4539,12 @@
           <a:p>
             <a:pPr indent="0" marL="0">
               <a:lnSpc>
-                <a:spcPts val="2000"/>
+                <a:spcPts val="1800"/>
               </a:lnSpc>
               <a:buNone/>
             </a:pPr>
             <a:r>
-              <a:rPr lang="en-US" sz="1300" dirty="0">
+              <a:rPr lang="en-US" sz="1250" dirty="0">
                 <a:solidFill>
                   <a:srgbClr val="9AB4A5"/>
                 </a:solidFill>
@@ -4545,26 +4554,26 @@
               </a:rPr>
               <a:t>• $5.7B Global Chess Industry: Rapid expansion fueled by streaming, youth adoption, and scholastic programs.</a:t>
             </a:r>
-            <a:endParaRPr lang="en-US" sz="1300" dirty="0"/>
+            <a:endParaRPr lang="en-US" sz="1250" dirty="0"/>
           </a:p>
           <a:p>
             <a:pPr indent="0" marL="0">
               <a:lnSpc>
-                <a:spcPts val="2000"/>
+                <a:spcPts val="1800"/>
               </a:lnSpc>
               <a:buNone/>
             </a:pPr>
-            <a:endParaRPr lang="en-US" sz="1300" dirty="0"/>
+            <a:endParaRPr lang="en-US" sz="1250" dirty="0"/>
           </a:p>
           <a:p>
             <a:pPr indent="0" marL="0">
               <a:lnSpc>
-                <a:spcPts val="2000"/>
+                <a:spcPts val="1800"/>
               </a:lnSpc>
               <a:buNone/>
             </a:pPr>
             <a:r>
-              <a:rPr lang="en-US" sz="1300" dirty="0">
+              <a:rPr lang="en-US" sz="1250" dirty="0">
                 <a:solidFill>
                   <a:srgbClr val="9AB4A5"/>
                 </a:solidFill>
@@ -4574,26 +4583,26 @@
               </a:rPr>
               <a:t>• 285M Visually Impaired Population: Completely excluded from competitive online chess due to visual interface lock-in.</a:t>
             </a:r>
-            <a:endParaRPr lang="en-US" sz="1300" dirty="0"/>
+            <a:endParaRPr lang="en-US" sz="1250" dirty="0"/>
           </a:p>
           <a:p>
             <a:pPr indent="0" marL="0">
               <a:lnSpc>
-                <a:spcPts val="2000"/>
+                <a:spcPts val="1800"/>
               </a:lnSpc>
               <a:buNone/>
             </a:pPr>
-            <a:endParaRPr lang="en-US" sz="1300" dirty="0"/>
+            <a:endParaRPr lang="en-US" sz="1250" dirty="0"/>
           </a:p>
           <a:p>
             <a:pPr indent="0" marL="0">
               <a:lnSpc>
-                <a:spcPts val="2000"/>
+                <a:spcPts val="1800"/>
               </a:lnSpc>
               <a:buNone/>
             </a:pPr>
             <a:r>
-              <a:rPr lang="en-US" sz="1300" dirty="0">
+              <a:rPr lang="en-US" sz="1250" dirty="0">
                 <a:solidFill>
                   <a:srgbClr val="9AB4A5"/>
                 </a:solidFill>
@@ -4603,7 +4612,7 @@
               </a:rPr>
               <a:t>• Category Creation: Neither Chess.com nor Lichess offer conversational hands-free voice gameplay today.</a:t>
             </a:r>
-            <a:endParaRPr lang="en-US" sz="1300" dirty="0"/>
+            <a:endParaRPr lang="en-US" sz="1250" dirty="0"/>
           </a:p>
         </p:txBody>
       </p:sp>
@@ -4615,8 +4624,8 @@
         </p:nvSpPr>
         <p:spPr>
           <a:xfrm>
-            <a:off x="6126480" y="1737360"/>
-            <a:ext cx="5303520" cy="4389120"/>
+            <a:off x="6263640" y="1600200"/>
+            <a:ext cx="5166360" cy="4389120"/>
           </a:xfrm>
           <a:prstGeom prst="roundRect">
             <a:avLst>
@@ -4656,8 +4665,8 @@
         </p:blipFill>
         <p:spPr>
           <a:xfrm>
-            <a:off x="6492240" y="2103120"/>
-            <a:ext cx="457200" cy="457200"/>
+            <a:off x="6583680" y="1920240"/>
+            <a:ext cx="411480" cy="411480"/>
           </a:xfrm>
           <a:prstGeom prst="rect">
             <a:avLst/>
@@ -4672,24 +4681,24 @@
         </p:nvSpPr>
         <p:spPr>
           <a:xfrm>
-            <a:off x="7040880" y="2148840"/>
-            <a:ext cx="4023360" cy="365760"/>
-          </a:xfrm>
-          <a:prstGeom prst="rect">
-            <a:avLst/>
-          </a:prstGeom>
-          <a:noFill/>
-          <a:ln/>
-        </p:spPr>
-        <p:txBody>
-          <a:bodyPr wrap="square" rtlCol="0" anchor="ctr"/>
-          <a:lstStyle/>
-          <a:p>
-            <a:pPr indent="0" marL="0">
-              <a:buNone/>
-            </a:pPr>
-            <a:r>
-              <a:rPr lang="en-US" sz="1800" b="1" dirty="0">
+            <a:off x="7132320" y="1965960"/>
+            <a:ext cx="4160520" cy="365760"/>
+          </a:xfrm>
+          <a:prstGeom prst="rect">
+            <a:avLst/>
+          </a:prstGeom>
+          <a:noFill/>
+          <a:ln/>
+        </p:spPr>
+        <p:txBody>
+          <a:bodyPr wrap="square" rtlCol="0" anchor="ctr"/>
+          <a:lstStyle/>
+          <a:p>
+            <a:pPr indent="0" marL="0">
+              <a:buNone/>
+            </a:pPr>
+            <a:r>
+              <a:rPr lang="en-US" sz="1700" b="1" dirty="0">
                 <a:solidFill>
                   <a:srgbClr val="FFFFFF"/>
                 </a:solidFill>
@@ -4699,7 +4708,7 @@
               </a:rPr>
               <a:t>Sustainable Revenue Streams</a:t>
             </a:r>
-            <a:endParaRPr lang="en-US" sz="1800" dirty="0"/>
+            <a:endParaRPr lang="en-US" sz="1700" dirty="0"/>
           </a:p>
         </p:txBody>
       </p:sp>
@@ -4711,8 +4720,8 @@
         </p:nvSpPr>
         <p:spPr>
           <a:xfrm>
-            <a:off x="6492240" y="2743200"/>
-            <a:ext cx="4572000" cy="3108960"/>
+            <a:off x="6583680" y="2560320"/>
+            <a:ext cx="4526280" cy="3108960"/>
           </a:xfrm>
           <a:prstGeom prst="rect">
             <a:avLst/>
@@ -4726,12 +4735,12 @@
           <a:p>
             <a:pPr indent="0" marL="0">
               <a:lnSpc>
-                <a:spcPts val="1800"/>
+                <a:spcPts val="1700"/>
               </a:lnSpc>
               <a:buNone/>
             </a:pPr>
             <a:r>
-              <a:rPr lang="en-US" sz="1300" dirty="0">
+              <a:rPr lang="en-US" sz="1200" dirty="0">
                 <a:solidFill>
                   <a:srgbClr val="9AB4A5"/>
                 </a:solidFill>
@@ -4741,17 +4750,17 @@
               </a:rPr>
               <a:t>1. Consumer Freemium (B2C)</a:t>
             </a:r>
-            <a:endParaRPr lang="en-US" sz="1300" dirty="0"/>
+            <a:endParaRPr lang="en-US" sz="1200" dirty="0"/>
           </a:p>
           <a:p>
             <a:pPr indent="0" marL="0">
               <a:lnSpc>
-                <a:spcPts val="1800"/>
+                <a:spcPts val="1700"/>
               </a:lnSpc>
               <a:buNone/>
             </a:pPr>
             <a:r>
-              <a:rPr lang="en-US" sz="1300" dirty="0">
+              <a:rPr lang="en-US" sz="1200" dirty="0">
                 <a:solidFill>
                   <a:srgbClr val="9AB4A5"/>
                 </a:solidFill>
@@ -4761,17 +4770,17 @@
               </a:rPr>
               <a:t>   • Free: Unlimited standard voice games &amp; clocks.</a:t>
             </a:r>
-            <a:endParaRPr lang="en-US" sz="1300" dirty="0"/>
+            <a:endParaRPr lang="en-US" sz="1200" dirty="0"/>
           </a:p>
           <a:p>
             <a:pPr indent="0" marL="0">
               <a:lnSpc>
-                <a:spcPts val="1800"/>
+                <a:spcPts val="1700"/>
               </a:lnSpc>
               <a:buNone/>
             </a:pPr>
             <a:r>
-              <a:rPr lang="en-US" sz="1300" dirty="0">
+              <a:rPr lang="en-US" sz="1200" dirty="0">
                 <a:solidFill>
                   <a:srgbClr val="9AB4A5"/>
                 </a:solidFill>
@@ -4781,26 +4790,26 @@
               </a:rPr>
               <a:t>   • Pro ($8/mo): Master-tier coaching, deep game evaluations, opening blunder audits.</a:t>
             </a:r>
-            <a:endParaRPr lang="en-US" sz="1300" dirty="0"/>
+            <a:endParaRPr lang="en-US" sz="1200" dirty="0"/>
           </a:p>
           <a:p>
             <a:pPr indent="0" marL="0">
               <a:lnSpc>
-                <a:spcPts val="1800"/>
+                <a:spcPts val="1700"/>
               </a:lnSpc>
               <a:buNone/>
             </a:pPr>
-            <a:endParaRPr lang="en-US" sz="1300" dirty="0"/>
+            <a:endParaRPr lang="en-US" sz="1200" dirty="0"/>
           </a:p>
           <a:p>
             <a:pPr indent="0" marL="0">
               <a:lnSpc>
-                <a:spcPts val="1800"/>
+                <a:spcPts val="1700"/>
               </a:lnSpc>
               <a:buNone/>
             </a:pPr>
             <a:r>
-              <a:rPr lang="en-US" sz="1300" dirty="0">
+              <a:rPr lang="en-US" sz="1200" dirty="0">
                 <a:solidFill>
                   <a:srgbClr val="9AB4A5"/>
                 </a:solidFill>
@@ -4810,17 +4819,17 @@
               </a:rPr>
               <a:t>2. Institutional &amp; Tournament Licensing (B2B)</a:t>
             </a:r>
-            <a:endParaRPr lang="en-US" sz="1300" dirty="0"/>
+            <a:endParaRPr lang="en-US" sz="1200" dirty="0"/>
           </a:p>
           <a:p>
             <a:pPr indent="0" marL="0">
               <a:lnSpc>
-                <a:spcPts val="1800"/>
+                <a:spcPts val="1700"/>
               </a:lnSpc>
               <a:buNone/>
             </a:pPr>
             <a:r>
-              <a:rPr lang="en-US" sz="1300" dirty="0">
+              <a:rPr lang="en-US" sz="1200" dirty="0">
                 <a:solidFill>
                   <a:srgbClr val="9AB4A5"/>
                 </a:solidFill>
@@ -4830,17 +4839,17 @@
               </a:rPr>
               <a:t>   • Official digital client for IBCA blind chess championships.</a:t>
             </a:r>
-            <a:endParaRPr lang="en-US" sz="1300" dirty="0"/>
+            <a:endParaRPr lang="en-US" sz="1200" dirty="0"/>
           </a:p>
           <a:p>
             <a:pPr indent="0" marL="0">
               <a:lnSpc>
-                <a:spcPts val="1800"/>
+                <a:spcPts val="1700"/>
               </a:lnSpc>
               <a:buNone/>
             </a:pPr>
             <a:r>
-              <a:rPr lang="en-US" sz="1300" dirty="0">
+              <a:rPr lang="en-US" sz="1200" dirty="0">
                 <a:solidFill>
                   <a:srgbClr val="9AB4A5"/>
                 </a:solidFill>
@@ -4850,26 +4859,26 @@
               </a:rPr>
               <a:t>   • White-label integration for schools and academies.</a:t>
             </a:r>
-            <a:endParaRPr lang="en-US" sz="1300" dirty="0"/>
+            <a:endParaRPr lang="en-US" sz="1200" dirty="0"/>
           </a:p>
           <a:p>
             <a:pPr indent="0" marL="0">
               <a:lnSpc>
-                <a:spcPts val="1800"/>
+                <a:spcPts val="1700"/>
               </a:lnSpc>
               <a:buNone/>
             </a:pPr>
-            <a:endParaRPr lang="en-US" sz="1300" dirty="0"/>
+            <a:endParaRPr lang="en-US" sz="1200" dirty="0"/>
           </a:p>
           <a:p>
             <a:pPr indent="0" marL="0">
               <a:lnSpc>
-                <a:spcPts val="1800"/>
+                <a:spcPts val="1700"/>
               </a:lnSpc>
               <a:buNone/>
             </a:pPr>
             <a:r>
-              <a:rPr lang="en-US" sz="1300" dirty="0">
+              <a:rPr lang="en-US" sz="1200" dirty="0">
                 <a:solidFill>
                   <a:srgbClr val="9AB4A5"/>
                 </a:solidFill>
@@ -4879,17 +4888,17 @@
               </a:rPr>
               <a:t>3. Voice Agent API Licensing</a:t>
             </a:r>
-            <a:endParaRPr lang="en-US" sz="1300" dirty="0"/>
+            <a:endParaRPr lang="en-US" sz="1200" dirty="0"/>
           </a:p>
           <a:p>
             <a:pPr indent="0" marL="0">
               <a:lnSpc>
-                <a:spcPts val="1800"/>
+                <a:spcPts val="1700"/>
               </a:lnSpc>
               <a:buNone/>
             </a:pPr>
             <a:r>
-              <a:rPr lang="en-US" sz="1300" dirty="0">
+              <a:rPr lang="en-US" sz="1200" dirty="0">
                 <a:solidFill>
                   <a:srgbClr val="9AB4A5"/>
                 </a:solidFill>
@@ -4899,7 +4908,7 @@
               </a:rPr>
               <a:t>   • Modular SDK for third-party chess software.</a:t>
             </a:r>
-            <a:endParaRPr lang="en-US" sz="1300" dirty="0"/>
+            <a:endParaRPr lang="en-US" sz="1200" dirty="0"/>
           </a:p>
         </p:txBody>
       </p:sp>
@@ -4943,7 +4952,7 @@
         </p:nvSpPr>
         <p:spPr>
           <a:xfrm>
-            <a:off x="731520" y="457200"/>
+            <a:off x="731520" y="411480"/>
             <a:ext cx="2011680" cy="292608"/>
           </a:xfrm>
           <a:prstGeom prst="roundRect">
@@ -4970,7 +4979,7 @@
         </p:nvSpPr>
         <p:spPr>
           <a:xfrm>
-            <a:off x="731520" y="457200"/>
+            <a:off x="731520" y="411480"/>
             <a:ext cx="2011680" cy="292608"/>
           </a:xfrm>
           <a:prstGeom prst="rect">
@@ -5009,24 +5018,24 @@
         </p:nvSpPr>
         <p:spPr>
           <a:xfrm>
-            <a:off x="731520" y="822960"/>
-            <a:ext cx="10515600" cy="640080"/>
-          </a:xfrm>
-          <a:prstGeom prst="rect">
-            <a:avLst/>
-          </a:prstGeom>
-          <a:noFill/>
-          <a:ln/>
-        </p:spPr>
-        <p:txBody>
-          <a:bodyPr wrap="square" rtlCol="0" anchor="ctr"/>
-          <a:lstStyle/>
-          <a:p>
-            <a:pPr indent="0" marL="0">
-              <a:buNone/>
-            </a:pPr>
-            <a:r>
-              <a:rPr lang="en-US" sz="2400" b="1" dirty="0">
+            <a:off x="731520" y="777240"/>
+            <a:ext cx="10698480" cy="594360"/>
+          </a:xfrm>
+          <a:prstGeom prst="rect">
+            <a:avLst/>
+          </a:prstGeom>
+          <a:noFill/>
+          <a:ln/>
+        </p:spPr>
+        <p:txBody>
+          <a:bodyPr wrap="square" rtlCol="0" anchor="ctr"/>
+          <a:lstStyle/>
+          <a:p>
+            <a:pPr indent="0" marL="0">
+              <a:buNone/>
+            </a:pPr>
+            <a:r>
+              <a:rPr lang="en-US" sz="2200" b="1" dirty="0">
                 <a:solidFill>
                   <a:srgbClr val="E8F4EE"/>
                 </a:solidFill>
@@ -5036,7 +5045,7 @@
               </a:rPr>
               <a:t>Strategic Roadmap: From AI Coach to Global Tournament Platform</a:t>
             </a:r>
-            <a:endParaRPr lang="en-US" sz="2400" dirty="0"/>
+            <a:endParaRPr lang="en-US" sz="2200" dirty="0"/>
           </a:p>
         </p:txBody>
       </p:sp>
@@ -5048,12 +5057,12 @@
         </p:nvSpPr>
         <p:spPr>
           <a:xfrm>
-            <a:off x="731520" y="1737360"/>
-            <a:ext cx="3429000" cy="4389120"/>
+            <a:off x="731520" y="1600200"/>
+            <a:ext cx="3337560" cy="4389120"/>
           </a:xfrm>
           <a:prstGeom prst="roundRect">
             <a:avLst>
-              <a:gd name="adj" fmla="val 4000"/>
+              <a:gd name="adj" fmla="val 4110"/>
             </a:avLst>
           </a:prstGeom>
           <a:solidFill>
@@ -5075,7 +5084,7 @@
         </p:nvSpPr>
         <p:spPr>
           <a:xfrm>
-            <a:off x="1097280" y="2103120"/>
+            <a:off x="1051560" y="1920240"/>
             <a:ext cx="2697480" cy="274320"/>
           </a:xfrm>
           <a:prstGeom prst="rect">
@@ -5114,24 +5123,24 @@
         </p:nvSpPr>
         <p:spPr>
           <a:xfrm>
-            <a:off x="1097280" y="2468880"/>
-            <a:ext cx="2697480" cy="640080"/>
-          </a:xfrm>
-          <a:prstGeom prst="rect">
-            <a:avLst/>
-          </a:prstGeom>
-          <a:noFill/>
-          <a:ln/>
-        </p:spPr>
-        <p:txBody>
-          <a:bodyPr wrap="square" rtlCol="0" anchor="ctr"/>
-          <a:lstStyle/>
-          <a:p>
-            <a:pPr indent="0" marL="0">
-              <a:buNone/>
-            </a:pPr>
-            <a:r>
-              <a:rPr lang="en-US" sz="1700" b="1" dirty="0">
+            <a:off x="1051560" y="2286000"/>
+            <a:ext cx="2697480" cy="548640"/>
+          </a:xfrm>
+          <a:prstGeom prst="rect">
+            <a:avLst/>
+          </a:prstGeom>
+          <a:noFill/>
+          <a:ln/>
+        </p:spPr>
+        <p:txBody>
+          <a:bodyPr wrap="square" rtlCol="0" anchor="ctr"/>
+          <a:lstStyle/>
+          <a:p>
+            <a:pPr indent="0" marL="0">
+              <a:buNone/>
+            </a:pPr>
+            <a:r>
+              <a:rPr lang="en-US" sz="1600" b="1" dirty="0">
                 <a:solidFill>
                   <a:srgbClr val="FFFFFF"/>
                 </a:solidFill>
@@ -5141,7 +5150,7 @@
               </a:rPr>
               <a:t>Autonomous AI Coach</a:t>
             </a:r>
-            <a:endParaRPr lang="en-US" sz="1700" dirty="0"/>
+            <a:endParaRPr lang="en-US" sz="1600" dirty="0"/>
           </a:p>
         </p:txBody>
       </p:sp>
@@ -5153,7 +5162,7 @@
         </p:nvSpPr>
         <p:spPr>
           <a:xfrm>
-            <a:off x="1097280" y="3291840"/>
+            <a:off x="1051560" y="3017520"/>
             <a:ext cx="2697480" cy="2560320"/>
           </a:xfrm>
           <a:prstGeom prst="rect">
@@ -5173,7 +5182,7 @@
               <a:buNone/>
             </a:pPr>
             <a:r>
-              <a:rPr lang="en-US" sz="1300" dirty="0">
+              <a:rPr lang="en-US" sz="1250" dirty="0">
                 <a:solidFill>
                   <a:srgbClr val="9AB4A5"/>
                 </a:solidFill>
@@ -5181,9 +5190,9 @@
                 <a:ea typeface="Arial" pitchFamily="34" charset="-122"/>
                 <a:cs typeface="Arial" pitchFamily="34" charset="-120"/>
               </a:rPr>
-              <a:t>Full conversational chess companion with AssemblyAI voice engine, Stockfish 16 WASM, blitz clocks, and 337 passing unit tests.</a:t>
-            </a:r>
-            <a:endParaRPr lang="en-US" sz="1300" dirty="0"/>
+              <a:t>Full conversational chess companion with AssemblyAI voice engine, Stockfish 16 WASM, blitz clocks, and 335 passing unit tests.</a:t>
+            </a:r>
+            <a:endParaRPr lang="en-US" sz="1250" dirty="0"/>
           </a:p>
         </p:txBody>
       </p:sp>
@@ -5195,12 +5204,12 @@
         </p:nvSpPr>
         <p:spPr>
           <a:xfrm>
-            <a:off x="4343400" y="1737360"/>
-            <a:ext cx="3429000" cy="4389120"/>
+            <a:off x="4416552" y="1600200"/>
+            <a:ext cx="3337560" cy="4389120"/>
           </a:xfrm>
           <a:prstGeom prst="roundRect">
             <a:avLst>
-              <a:gd name="adj" fmla="val 4000"/>
+              <a:gd name="adj" fmla="val 4110"/>
             </a:avLst>
           </a:prstGeom>
           <a:solidFill>
@@ -5222,7 +5231,7 @@
         </p:nvSpPr>
         <p:spPr>
           <a:xfrm>
-            <a:off x="4709160" y="2103120"/>
+            <a:off x="4736592" y="1920240"/>
             <a:ext cx="2697480" cy="274320"/>
           </a:xfrm>
           <a:prstGeom prst="rect">
@@ -5261,24 +5270,24 @@
         </p:nvSpPr>
         <p:spPr>
           <a:xfrm>
-            <a:off x="4709160" y="2468880"/>
-            <a:ext cx="2697480" cy="640080"/>
-          </a:xfrm>
-          <a:prstGeom prst="rect">
-            <a:avLst/>
-          </a:prstGeom>
-          <a:noFill/>
-          <a:ln/>
-        </p:spPr>
-        <p:txBody>
-          <a:bodyPr wrap="square" rtlCol="0" anchor="ctr"/>
-          <a:lstStyle/>
-          <a:p>
-            <a:pPr indent="0" marL="0">
-              <a:buNone/>
-            </a:pPr>
-            <a:r>
-              <a:rPr lang="en-US" sz="1700" b="1" dirty="0">
+            <a:off x="4736592" y="2286000"/>
+            <a:ext cx="2697480" cy="548640"/>
+          </a:xfrm>
+          <a:prstGeom prst="rect">
+            <a:avLst/>
+          </a:prstGeom>
+          <a:noFill/>
+          <a:ln/>
+        </p:spPr>
+        <p:txBody>
+          <a:bodyPr wrap="square" rtlCol="0" anchor="ctr"/>
+          <a:lstStyle/>
+          <a:p>
+            <a:pPr indent="0" marL="0">
+              <a:buNone/>
+            </a:pPr>
+            <a:r>
+              <a:rPr lang="en-US" sz="1600" b="1" dirty="0">
                 <a:solidFill>
                   <a:srgbClr val="FFFFFF"/>
                 </a:solidFill>
@@ -5288,7 +5297,7 @@
               </a:rPr>
               <a:t>Peer-to-Peer Voice Rooms</a:t>
             </a:r>
-            <a:endParaRPr lang="en-US" sz="1700" dirty="0"/>
+            <a:endParaRPr lang="en-US" sz="1600" dirty="0"/>
           </a:p>
         </p:txBody>
       </p:sp>
@@ -5300,7 +5309,7 @@
         </p:nvSpPr>
         <p:spPr>
           <a:xfrm>
-            <a:off x="4709160" y="3291840"/>
+            <a:off x="4736592" y="3017520"/>
             <a:ext cx="2697480" cy="2560320"/>
           </a:xfrm>
           <a:prstGeom prst="rect">
@@ -5320,7 +5329,7 @@
               <a:buNone/>
             </a:pPr>
             <a:r>
-              <a:rPr lang="en-US" sz="1300" dirty="0">
+              <a:rPr lang="en-US" sz="1250" dirty="0">
                 <a:solidFill>
                   <a:srgbClr val="9AB4A5"/>
                 </a:solidFill>
@@ -5330,7 +5339,7 @@
               </a:rPr>
               <a:t>Real-time human-vs-human voice chess rooms. Auditory clock countdowns and rated match synchronization with Lichess.</a:t>
             </a:r>
-            <a:endParaRPr lang="en-US" sz="1300" dirty="0"/>
+            <a:endParaRPr lang="en-US" sz="1250" dirty="0"/>
           </a:p>
         </p:txBody>
       </p:sp>
@@ -5342,12 +5351,12 @@
         </p:nvSpPr>
         <p:spPr>
           <a:xfrm>
-            <a:off x="7955280" y="1737360"/>
-            <a:ext cx="3429000" cy="4389120"/>
+            <a:off x="8101584" y="1600200"/>
+            <a:ext cx="3337560" cy="4389120"/>
           </a:xfrm>
           <a:prstGeom prst="roundRect">
             <a:avLst>
-              <a:gd name="adj" fmla="val 4000"/>
+              <a:gd name="adj" fmla="val 4110"/>
             </a:avLst>
           </a:prstGeom>
           <a:solidFill>
@@ -5369,7 +5378,7 @@
         </p:nvSpPr>
         <p:spPr>
           <a:xfrm>
-            <a:off x="8321040" y="2103120"/>
+            <a:off x="8421624" y="1920240"/>
             <a:ext cx="2697480" cy="274320"/>
           </a:xfrm>
           <a:prstGeom prst="rect">
@@ -5408,24 +5417,24 @@
         </p:nvSpPr>
         <p:spPr>
           <a:xfrm>
-            <a:off x="8321040" y="2468880"/>
-            <a:ext cx="2697480" cy="640080"/>
-          </a:xfrm>
-          <a:prstGeom prst="rect">
-            <a:avLst/>
-          </a:prstGeom>
-          <a:noFill/>
-          <a:ln/>
-        </p:spPr>
-        <p:txBody>
-          <a:bodyPr wrap="square" rtlCol="0" anchor="ctr"/>
-          <a:lstStyle/>
-          <a:p>
-            <a:pPr indent="0" marL="0">
-              <a:buNone/>
-            </a:pPr>
-            <a:r>
-              <a:rPr lang="en-US" sz="1700" b="1" dirty="0">
+            <a:off x="8421624" y="2286000"/>
+            <a:ext cx="2697480" cy="548640"/>
+          </a:xfrm>
+          <a:prstGeom prst="rect">
+            <a:avLst/>
+          </a:prstGeom>
+          <a:noFill/>
+          <a:ln/>
+        </p:spPr>
+        <p:txBody>
+          <a:bodyPr wrap="square" rtlCol="0" anchor="ctr"/>
+          <a:lstStyle/>
+          <a:p>
+            <a:pPr indent="0" marL="0">
+              <a:buNone/>
+            </a:pPr>
+            <a:r>
+              <a:rPr lang="en-US" sz="1600" b="1" dirty="0">
                 <a:solidFill>
                   <a:srgbClr val="FFFFFF"/>
                 </a:solidFill>
@@ -5433,9 +5442,9 @@
                 <a:ea typeface="Arial" pitchFamily="34" charset="-122"/>
                 <a:cs typeface="Arial" pitchFamily="34" charset="-120"/>
               </a:rPr>
-              <a:t>Hardware &amp; Multilingual Scale</a:t>
-            </a:r>
-            <a:endParaRPr lang="en-US" sz="1700" dirty="0"/>
+              <a:t>Hardware &amp; Scale</a:t>
+            </a:r>
+            <a:endParaRPr lang="en-US" sz="1600" dirty="0"/>
           </a:p>
         </p:txBody>
       </p:sp>
@@ -5447,7 +5456,7 @@
         </p:nvSpPr>
         <p:spPr>
           <a:xfrm>
-            <a:off x="8321040" y="3291840"/>
+            <a:off x="8421624" y="3017520"/>
             <a:ext cx="2697480" cy="2560320"/>
           </a:xfrm>
           <a:prstGeom prst="rect">
@@ -5467,7 +5476,7 @@
               <a:buNone/>
             </a:pPr>
             <a:r>
-              <a:rPr lang="en-US" sz="1300" dirty="0">
+              <a:rPr lang="en-US" sz="1250" dirty="0">
                 <a:solidFill>
                   <a:srgbClr val="9AB4A5"/>
                 </a:solidFill>
@@ -5477,7 +5486,7 @@
               </a:rPr>
               <a:t>Bluetooth electronic chess board sync (DGT, Millennium), haptic move feedback, and multilingual IBCA speech models in 8 languages.</a:t>
             </a:r>
-            <a:endParaRPr lang="en-US" sz="1300" dirty="0"/>
+            <a:endParaRPr lang="en-US" sz="1250" dirty="0"/>
           </a:p>
         </p:txBody>
       </p:sp>
@@ -5521,7 +5530,7 @@
         </p:nvSpPr>
         <p:spPr>
           <a:xfrm>
-            <a:off x="731520" y="457200"/>
+            <a:off x="731520" y="411480"/>
             <a:ext cx="2011680" cy="292608"/>
           </a:xfrm>
           <a:prstGeom prst="roundRect">
@@ -5548,7 +5557,7 @@
         </p:nvSpPr>
         <p:spPr>
           <a:xfrm>
-            <a:off x="731520" y="457200"/>
+            <a:off x="731520" y="411480"/>
             <a:ext cx="2011680" cy="292608"/>
           </a:xfrm>
           <a:prstGeom prst="rect">
@@ -5587,24 +5596,24 @@
         </p:nvSpPr>
         <p:spPr>
           <a:xfrm>
-            <a:off x="731520" y="822960"/>
-            <a:ext cx="10515600" cy="640080"/>
-          </a:xfrm>
-          <a:prstGeom prst="rect">
-            <a:avLst/>
-          </a:prstGeom>
-          <a:noFill/>
-          <a:ln/>
-        </p:spPr>
-        <p:txBody>
-          <a:bodyPr wrap="square" rtlCol="0" anchor="ctr"/>
-          <a:lstStyle/>
-          <a:p>
-            <a:pPr indent="0" marL="0">
-              <a:buNone/>
-            </a:pPr>
-            <a:r>
-              <a:rPr lang="en-US" sz="2400" b="1" dirty="0">
+            <a:off x="731520" y="777240"/>
+            <a:ext cx="10698480" cy="594360"/>
+          </a:xfrm>
+          <a:prstGeom prst="rect">
+            <a:avLst/>
+          </a:prstGeom>
+          <a:noFill/>
+          <a:ln/>
+        </p:spPr>
+        <p:txBody>
+          <a:bodyPr wrap="square" rtlCol="0" anchor="ctr"/>
+          <a:lstStyle/>
+          <a:p>
+            <a:pPr indent="0" marL="0">
+              <a:buNone/>
+            </a:pPr>
+            <a:r>
+              <a:rPr lang="en-US" sz="2200" b="1" dirty="0">
                 <a:solidFill>
                   <a:srgbClr val="E8F4EE"/>
                 </a:solidFill>
@@ -5614,7 +5623,7 @@
               </a:rPr>
               <a:t>Immediate Next Steps with Additional Time &amp; Resources</a:t>
             </a:r>
-            <a:endParaRPr lang="en-US" sz="2400" dirty="0"/>
+            <a:endParaRPr lang="en-US" sz="2200" dirty="0"/>
           </a:p>
         </p:txBody>
       </p:sp>
@@ -5626,7 +5635,7 @@
         </p:nvSpPr>
         <p:spPr>
           <a:xfrm>
-            <a:off x="731520" y="1737360"/>
+            <a:off x="731520" y="1600200"/>
             <a:ext cx="5166360" cy="2057400"/>
           </a:xfrm>
           <a:prstGeom prst="roundRect">
@@ -5667,7 +5676,7 @@
         </p:blipFill>
         <p:spPr>
           <a:xfrm>
-            <a:off x="1051560" y="2057400"/>
+            <a:off x="1051560" y="1874520"/>
             <a:ext cx="411480" cy="411480"/>
           </a:xfrm>
           <a:prstGeom prst="rect">
@@ -5683,24 +5692,24 @@
         </p:nvSpPr>
         <p:spPr>
           <a:xfrm>
-            <a:off x="1600200" y="2011680"/>
-            <a:ext cx="4023360" cy="365760"/>
-          </a:xfrm>
-          <a:prstGeom prst="rect">
-            <a:avLst/>
-          </a:prstGeom>
-          <a:noFill/>
-          <a:ln/>
-        </p:spPr>
-        <p:txBody>
-          <a:bodyPr wrap="square" rtlCol="0" anchor="ctr"/>
-          <a:lstStyle/>
-          <a:p>
-            <a:pPr indent="0" marL="0">
-              <a:buNone/>
-            </a:pPr>
-            <a:r>
-              <a:rPr lang="en-US" sz="1500" b="1" dirty="0">
+            <a:off x="1600200" y="1828800"/>
+            <a:ext cx="4160520" cy="320040"/>
+          </a:xfrm>
+          <a:prstGeom prst="rect">
+            <a:avLst/>
+          </a:prstGeom>
+          <a:noFill/>
+          <a:ln/>
+        </p:spPr>
+        <p:txBody>
+          <a:bodyPr wrap="square" rtlCol="0" anchor="ctr"/>
+          <a:lstStyle/>
+          <a:p>
+            <a:pPr indent="0" marL="0">
+              <a:buNone/>
+            </a:pPr>
+            <a:r>
+              <a:rPr lang="en-US" sz="1450" b="1" dirty="0">
                 <a:solidFill>
                   <a:srgbClr val="FFFFFF"/>
                 </a:solidFill>
@@ -5708,9 +5717,9 @@
                 <a:ea typeface="Arial" pitchFamily="34" charset="-122"/>
                 <a:cs typeface="Arial" pitchFamily="34" charset="-120"/>
               </a:rPr>
-              <a:t>1. Real-Time Voice-to-Voice Multiplayer</a:t>
-            </a:r>
-            <a:endParaRPr lang="en-US" sz="1500" dirty="0"/>
+              <a:t>1. Voice-to-Voice Multiplayer</a:t>
+            </a:r>
+            <a:endParaRPr lang="en-US" sz="1450" dirty="0"/>
           </a:p>
         </p:txBody>
       </p:sp>
@@ -5722,8 +5731,8 @@
         </p:nvSpPr>
         <p:spPr>
           <a:xfrm>
-            <a:off x="1051560" y="2560320"/>
-            <a:ext cx="4526280" cy="1051560"/>
+            <a:off x="1051560" y="2377440"/>
+            <a:ext cx="4526280" cy="1143000"/>
           </a:xfrm>
           <a:prstGeom prst="rect">
             <a:avLst/>
@@ -5737,12 +5746,12 @@
           <a:p>
             <a:pPr indent="0" marL="0">
               <a:lnSpc>
-                <a:spcPts val="1700"/>
+                <a:spcPts val="1600"/>
               </a:lnSpc>
               <a:buNone/>
             </a:pPr>
             <a:r>
-              <a:rPr lang="en-US" sz="1200" dirty="0">
+              <a:rPr lang="en-US" sz="1150" dirty="0">
                 <a:solidFill>
                   <a:srgbClr val="9AB4A5"/>
                 </a:solidFill>
@@ -5752,7 +5761,7 @@
               </a:rPr>
               <a:t>Pair two blind players in a shared voice channel where both players' spoken moves and clock sounds are broadcast and verified in sub-second real time.</a:t>
             </a:r>
-            <a:endParaRPr lang="en-US" sz="1200" dirty="0"/>
+            <a:endParaRPr lang="en-US" sz="1150" dirty="0"/>
           </a:p>
         </p:txBody>
       </p:sp>
@@ -5764,7 +5773,7 @@
         </p:nvSpPr>
         <p:spPr>
           <a:xfrm>
-            <a:off x="6126480" y="1737360"/>
+            <a:off x="6263640" y="1600200"/>
             <a:ext cx="5166360" cy="2057400"/>
           </a:xfrm>
           <a:prstGeom prst="roundRect">
@@ -5805,7 +5814,7 @@
         </p:blipFill>
         <p:spPr>
           <a:xfrm>
-            <a:off x="6446520" y="2057400"/>
+            <a:off x="6583680" y="1874520"/>
             <a:ext cx="411480" cy="411480"/>
           </a:xfrm>
           <a:prstGeom prst="rect">
@@ -5821,24 +5830,24 @@
         </p:nvSpPr>
         <p:spPr>
           <a:xfrm>
-            <a:off x="6995160" y="2011680"/>
-            <a:ext cx="4023360" cy="365760"/>
-          </a:xfrm>
-          <a:prstGeom prst="rect">
-            <a:avLst/>
-          </a:prstGeom>
-          <a:noFill/>
-          <a:ln/>
-        </p:spPr>
-        <p:txBody>
-          <a:bodyPr wrap="square" rtlCol="0" anchor="ctr"/>
-          <a:lstStyle/>
-          <a:p>
-            <a:pPr indent="0" marL="0">
-              <a:buNone/>
-            </a:pPr>
-            <a:r>
-              <a:rPr lang="en-US" sz="1500" b="1" dirty="0">
+            <a:off x="7132320" y="1828800"/>
+            <a:ext cx="4160520" cy="320040"/>
+          </a:xfrm>
+          <a:prstGeom prst="rect">
+            <a:avLst/>
+          </a:prstGeom>
+          <a:noFill/>
+          <a:ln/>
+        </p:spPr>
+        <p:txBody>
+          <a:bodyPr wrap="square" rtlCol="0" anchor="ctr"/>
+          <a:lstStyle/>
+          <a:p>
+            <a:pPr indent="0" marL="0">
+              <a:buNone/>
+            </a:pPr>
+            <a:r>
+              <a:rPr lang="en-US" sz="1450" b="1" dirty="0">
                 <a:solidFill>
                   <a:srgbClr val="FFFFFF"/>
                 </a:solidFill>
@@ -5848,7 +5857,7 @@
               </a:rPr>
               <a:t>2. Haptic Coordinate Feedback</a:t>
             </a:r>
-            <a:endParaRPr lang="en-US" sz="1500" dirty="0"/>
+            <a:endParaRPr lang="en-US" sz="1450" dirty="0"/>
           </a:p>
         </p:txBody>
       </p:sp>
@@ -5860,8 +5869,8 @@
         </p:nvSpPr>
         <p:spPr>
           <a:xfrm>
-            <a:off x="6446520" y="2560320"/>
-            <a:ext cx="4526280" cy="1051560"/>
+            <a:off x="6583680" y="2377440"/>
+            <a:ext cx="4526280" cy="1143000"/>
           </a:xfrm>
           <a:prstGeom prst="rect">
             <a:avLst/>
@@ -5875,12 +5884,12 @@
           <a:p>
             <a:pPr indent="0" marL="0">
               <a:lnSpc>
-                <a:spcPts val="1700"/>
+                <a:spcPts val="1600"/>
               </a:lnSpc>
               <a:buNone/>
             </a:pPr>
             <a:r>
-              <a:rPr lang="en-US" sz="1200" dirty="0">
+              <a:rPr lang="en-US" sz="1150" dirty="0">
                 <a:solidFill>
                   <a:srgbClr val="9AB4A5"/>
                 </a:solidFill>
@@ -5890,7 +5899,7 @@
               </a:rPr>
               <a:t>Encode square files (1-8) and ranks (a-h) into distinct spatial vibration patterns on mobile devices, allowing tactile verification without any audio.</a:t>
             </a:r>
-            <a:endParaRPr lang="en-US" sz="1200" dirty="0"/>
+            <a:endParaRPr lang="en-US" sz="1150" dirty="0"/>
           </a:p>
         </p:txBody>
       </p:sp>
@@ -5902,7 +5911,7 @@
         </p:nvSpPr>
         <p:spPr>
           <a:xfrm>
-            <a:off x="731520" y="3977640"/>
+            <a:off x="731520" y="3931920"/>
             <a:ext cx="5166360" cy="2057400"/>
           </a:xfrm>
           <a:prstGeom prst="roundRect">
@@ -5943,7 +5952,7 @@
         </p:blipFill>
         <p:spPr>
           <a:xfrm>
-            <a:off x="1051560" y="4297680"/>
+            <a:off x="1051560" y="4206240"/>
             <a:ext cx="411480" cy="411480"/>
           </a:xfrm>
           <a:prstGeom prst="rect">
@@ -5959,24 +5968,24 @@
         </p:nvSpPr>
         <p:spPr>
           <a:xfrm>
-            <a:off x="1600200" y="4251960"/>
-            <a:ext cx="4023360" cy="365760"/>
-          </a:xfrm>
-          <a:prstGeom prst="rect">
-            <a:avLst/>
-          </a:prstGeom>
-          <a:noFill/>
-          <a:ln/>
-        </p:spPr>
-        <p:txBody>
-          <a:bodyPr wrap="square" rtlCol="0" anchor="ctr"/>
-          <a:lstStyle/>
-          <a:p>
-            <a:pPr indent="0" marL="0">
-              <a:buNone/>
-            </a:pPr>
-            <a:r>
-              <a:rPr lang="en-US" sz="1500" b="1" dirty="0">
+            <a:off x="1600200" y="4160520"/>
+            <a:ext cx="4160520" cy="320040"/>
+          </a:xfrm>
+          <a:prstGeom prst="rect">
+            <a:avLst/>
+          </a:prstGeom>
+          <a:noFill/>
+          <a:ln/>
+        </p:spPr>
+        <p:txBody>
+          <a:bodyPr wrap="square" rtlCol="0" anchor="ctr"/>
+          <a:lstStyle/>
+          <a:p>
+            <a:pPr indent="0" marL="0">
+              <a:buNone/>
+            </a:pPr>
+            <a:r>
+              <a:rPr lang="en-US" sz="1450" b="1" dirty="0">
                 <a:solidFill>
                   <a:srgbClr val="FFFFFF"/>
                 </a:solidFill>
@@ -5984,9 +5993,9 @@
                 <a:ea typeface="Arial" pitchFamily="34" charset="-122"/>
                 <a:cs typeface="Arial" pitchFamily="34" charset="-120"/>
               </a:rPr>
-              <a:t>3. IBCA Certified Tournament Arbiter Mode</a:t>
-            </a:r>
-            <a:endParaRPr lang="en-US" sz="1500" dirty="0"/>
+              <a:t>3. IBCA Certified Tournament Arbiter</a:t>
+            </a:r>
+            <a:endParaRPr lang="en-US" sz="1450" dirty="0"/>
           </a:p>
         </p:txBody>
       </p:sp>
@@ -5998,8 +6007,8 @@
         </p:nvSpPr>
         <p:spPr>
           <a:xfrm>
-            <a:off x="1051560" y="4800600"/>
-            <a:ext cx="4526280" cy="1051560"/>
+            <a:off x="1051560" y="4709160"/>
+            <a:ext cx="4526280" cy="1143000"/>
           </a:xfrm>
           <a:prstGeom prst="rect">
             <a:avLst/>
@@ -6013,12 +6022,12 @@
           <a:p>
             <a:pPr indent="0" marL="0">
               <a:lnSpc>
-                <a:spcPts val="1700"/>
+                <a:spcPts val="1600"/>
               </a:lnSpc>
               <a:buNone/>
             </a:pPr>
             <a:r>
-              <a:rPr lang="en-US" sz="1200" dirty="0">
+              <a:rPr lang="en-US" sz="1150" dirty="0">
                 <a:solidFill>
                   <a:srgbClr val="9AB4A5"/>
                 </a:solidFill>
@@ -6028,7 +6037,7 @@
               </a:rPr>
               <a:t>Digital adjudication engine generating FIDE-compliant PGN score-sheets with automated dispute playback for blind chess tournament organizers.</a:t>
             </a:r>
-            <a:endParaRPr lang="en-US" sz="1200" dirty="0"/>
+            <a:endParaRPr lang="en-US" sz="1150" dirty="0"/>
           </a:p>
         </p:txBody>
       </p:sp>
@@ -6040,7 +6049,7 @@
         </p:nvSpPr>
         <p:spPr>
           <a:xfrm>
-            <a:off x="6126480" y="3977640"/>
+            <a:off x="6263640" y="3931920"/>
             <a:ext cx="5166360" cy="2057400"/>
           </a:xfrm>
           <a:prstGeom prst="roundRect">
@@ -6081,7 +6090,7 @@
         </p:blipFill>
         <p:spPr>
           <a:xfrm>
-            <a:off x="6446520" y="4297680"/>
+            <a:off x="6583680" y="4206240"/>
             <a:ext cx="411480" cy="411480"/>
           </a:xfrm>
           <a:prstGeom prst="rect">
@@ -6097,24 +6106,24 @@
         </p:nvSpPr>
         <p:spPr>
           <a:xfrm>
-            <a:off x="6995160" y="4251960"/>
-            <a:ext cx="4023360" cy="365760"/>
-          </a:xfrm>
-          <a:prstGeom prst="rect">
-            <a:avLst/>
-          </a:prstGeom>
-          <a:noFill/>
-          <a:ln/>
-        </p:spPr>
-        <p:txBody>
-          <a:bodyPr wrap="square" rtlCol="0" anchor="ctr"/>
-          <a:lstStyle/>
-          <a:p>
-            <a:pPr indent="0" marL="0">
-              <a:buNone/>
-            </a:pPr>
-            <a:r>
-              <a:rPr lang="en-US" sz="1500" b="1" dirty="0">
+            <a:off x="7132320" y="4160520"/>
+            <a:ext cx="4160520" cy="320040"/>
+          </a:xfrm>
+          <a:prstGeom prst="rect">
+            <a:avLst/>
+          </a:prstGeom>
+          <a:noFill/>
+          <a:ln/>
+        </p:spPr>
+        <p:txBody>
+          <a:bodyPr wrap="square" rtlCol="0" anchor="ctr"/>
+          <a:lstStyle/>
+          <a:p>
+            <a:pPr indent="0" marL="0">
+              <a:buNone/>
+            </a:pPr>
+            <a:r>
+              <a:rPr lang="en-US" sz="1450" b="1" dirty="0">
                 <a:solidFill>
                   <a:srgbClr val="FFFFFF"/>
                 </a:solidFill>
@@ -6122,9 +6131,9 @@
                 <a:ea typeface="Arial" pitchFamily="34" charset="-122"/>
                 <a:cs typeface="Arial" pitchFamily="34" charset="-120"/>
               </a:rPr>
-              <a:t>4. Native iOS &amp; Android Packaged Apps</a:t>
-            </a:r>
-            <a:endParaRPr lang="en-US" sz="1500" dirty="0"/>
+              <a:t>4. Native iOS &amp; Android Apps</a:t>
+            </a:r>
+            <a:endParaRPr lang="en-US" sz="1450" dirty="0"/>
           </a:p>
         </p:txBody>
       </p:sp>
@@ -6136,8 +6145,8 @@
         </p:nvSpPr>
         <p:spPr>
           <a:xfrm>
-            <a:off x="6446520" y="4800600"/>
-            <a:ext cx="4526280" cy="1051560"/>
+            <a:off x="6583680" y="4709160"/>
+            <a:ext cx="4526280" cy="1143000"/>
           </a:xfrm>
           <a:prstGeom prst="rect">
             <a:avLst/>
@@ -6151,12 +6160,12 @@
           <a:p>
             <a:pPr indent="0" marL="0">
               <a:lnSpc>
-                <a:spcPts val="1700"/>
+                <a:spcPts val="1600"/>
               </a:lnSpc>
               <a:buNone/>
             </a:pPr>
             <a:r>
-              <a:rPr lang="en-US" sz="1200" dirty="0">
+              <a:rPr lang="en-US" sz="1150" dirty="0">
                 <a:solidFill>
                   <a:srgbClr val="9AB4A5"/>
                 </a:solidFill>
@@ -6166,7 +6175,7 @@
               </a:rPr>
               <a:t>Package the Web Audio and AssemblyAI pipeline into native mobile apps utilizing iOS CoreAudio and Android AudioTrack for maximum battery efficiency.</a:t>
             </a:r>
-            <a:endParaRPr lang="en-US" sz="1200" dirty="0"/>
+            <a:endParaRPr lang="en-US" sz="1150" dirty="0"/>
           </a:p>
         </p:txBody>
       </p:sp>

</xml_diff>

<commit_message>
docs: add live Vercel production URL https://voicechessmate.vercel.app/ to README, PPTX, and HTML presentation decks
</commit_message>
<xml_diff>
--- a/VoiceChessmate_HACKDAY_1.0.pptx
+++ b/VoiceChessmate_HACKDAY_1.0.pptx
@@ -2170,7 +2170,7 @@
         <p:spPr>
           <a:xfrm>
             <a:off x="1051560" y="2606040"/>
-            <a:ext cx="4526280" cy="3017520"/>
+            <a:ext cx="4526280" cy="3108960"/>
           </a:xfrm>
           <a:prstGeom prst="rect">
             <a:avLst/>
@@ -2184,12 +2184,12 @@
           <a:p>
             <a:pPr indent="0" marL="0">
               <a:lnSpc>
-                <a:spcPts val="1900"/>
+                <a:spcPts val="1700"/>
               </a:lnSpc>
               <a:buNone/>
             </a:pPr>
             <a:r>
-              <a:rPr lang="en-US" sz="1300" dirty="0">
+              <a:rPr lang="en-US" sz="1200" dirty="0">
                 <a:solidFill>
                   <a:srgbClr val="9AB4A5"/>
                 </a:solidFill>
@@ -2199,17 +2199,17 @@
               </a:rPr>
               <a:t>Players simply hold 'J' (push-to-talk) and speak naturally:</a:t>
             </a:r>
-            <a:endParaRPr lang="en-US" sz="1300" dirty="0"/>
+            <a:endParaRPr lang="en-US" sz="1200" dirty="0"/>
           </a:p>
           <a:p>
             <a:pPr indent="0" marL="0">
               <a:lnSpc>
-                <a:spcPts val="1900"/>
+                <a:spcPts val="1700"/>
               </a:lnSpc>
               <a:buNone/>
             </a:pPr>
             <a:r>
-              <a:rPr lang="en-US" sz="1300" dirty="0">
+              <a:rPr lang="en-US" sz="1200" dirty="0">
                 <a:solidFill>
                   <a:srgbClr val="9AB4A5"/>
                 </a:solidFill>
@@ -2219,17 +2219,17 @@
               </a:rPr>
               <a:t>  • 'Knight to f3' or 'Pawn to Eva 4'</a:t>
             </a:r>
-            <a:endParaRPr lang="en-US" sz="1300" dirty="0"/>
+            <a:endParaRPr lang="en-US" sz="1200" dirty="0"/>
           </a:p>
           <a:p>
             <a:pPr indent="0" marL="0">
               <a:lnSpc>
-                <a:spcPts val="1900"/>
+                <a:spcPts val="1700"/>
               </a:lnSpc>
               <a:buNone/>
             </a:pPr>
             <a:r>
-              <a:rPr lang="en-US" sz="1300" dirty="0">
+              <a:rPr lang="en-US" sz="1200" dirty="0">
                 <a:solidFill>
                   <a:srgbClr val="9AB4A5"/>
                 </a:solidFill>
@@ -2239,26 +2239,26 @@
               </a:rPr>
               <a:t>  • 'Describe my threats' or 'What is my best development?'</a:t>
             </a:r>
-            <a:endParaRPr lang="en-US" sz="1300" dirty="0"/>
+            <a:endParaRPr lang="en-US" sz="1200" dirty="0"/>
           </a:p>
           <a:p>
             <a:pPr indent="0" marL="0">
               <a:lnSpc>
-                <a:spcPts val="1900"/>
+                <a:spcPts val="1700"/>
               </a:lnSpc>
               <a:buNone/>
             </a:pPr>
-            <a:endParaRPr lang="en-US" sz="1300" dirty="0"/>
+            <a:endParaRPr lang="en-US" sz="1200" dirty="0"/>
           </a:p>
           <a:p>
             <a:pPr indent="0" marL="0">
               <a:lnSpc>
-                <a:spcPts val="1900"/>
+                <a:spcPts val="1700"/>
               </a:lnSpc>
               <a:buNone/>
             </a:pPr>
             <a:r>
-              <a:rPr lang="en-US" sz="1300" dirty="0">
+              <a:rPr lang="en-US" sz="1200" dirty="0">
                 <a:solidFill>
                   <a:srgbClr val="9AB4A5"/>
                 </a:solidFill>
@@ -2268,7 +2268,36 @@
               </a:rPr>
               <a:t>The Voice Agent immediately confirms moves, executes the AI reply, and speaks tactical coaching guidance back with zero screen dependency.</a:t>
             </a:r>
-            <a:endParaRPr lang="en-US" sz="1300" dirty="0"/>
+            <a:endParaRPr lang="en-US" sz="1200" dirty="0"/>
+          </a:p>
+          <a:p>
+            <a:pPr indent="0" marL="0">
+              <a:lnSpc>
+                <a:spcPts val="1700"/>
+              </a:lnSpc>
+              <a:buNone/>
+            </a:pPr>
+            <a:endParaRPr lang="en-US" sz="1200" dirty="0"/>
+          </a:p>
+          <a:p>
+            <a:pPr indent="0" marL="0">
+              <a:lnSpc>
+                <a:spcPts val="1700"/>
+              </a:lnSpc>
+              <a:buNone/>
+            </a:pPr>
+            <a:r>
+              <a:rPr lang="en-US" sz="1200" dirty="0">
+                <a:solidFill>
+                  <a:srgbClr val="9AB4A5"/>
+                </a:solidFill>
+                <a:latin typeface="Arial" pitchFamily="34" charset="0"/>
+                <a:ea typeface="Arial" pitchFamily="34" charset="-122"/>
+                <a:cs typeface="Arial" pitchFamily="34" charset="-120"/>
+              </a:rPr>
+              <a:t>Live Production App: https://voicechessmate.vercel.app/</a:t>
+            </a:r>
+            <a:endParaRPr lang="en-US" sz="1200" dirty="0"/>
           </a:p>
         </p:txBody>
       </p:sp>

</xml_diff>